<commit_message>
feat(project-02): finalize 100% complete implementation, models, tests, docs, PPT, and video demonstration for PROJECT-002
</commit_message>
<xml_diff>
--- a/project_02_network_intrusion_anomaly/presentations/project_presentation.pptx
+++ b/project_02_network_intrusion_anomaly/presentations/project_presentation.pptx
@@ -13,6 +13,13 @@
     <p:sldId id="261" r:id="rId12"/>
     <p:sldId id="262" r:id="rId13"/>
     <p:sldId id="263" r:id="rId14"/>
+    <p:sldId id="264" r:id="rId15"/>
+    <p:sldId id="265" r:id="rId16"/>
+    <p:sldId id="266" r:id="rId17"/>
+    <p:sldId id="267" r:id="rId18"/>
+    <p:sldId id="268" r:id="rId19"/>
+    <p:sldId id="269" r:id="rId20"/>
+    <p:sldId id="270" r:id="rId21"/>
   </p:sldIdLst>
   <p:sldSz cx="12191695" cy="6858000" type="screen4x3"/>
   <p:notesSz cx="6858000" cy="9144000"/>
@@ -3110,7 +3117,7 @@
             <a:avLst/>
           </a:prstGeom>
           <a:solidFill>
-            <a:srgbClr val="0F172A"/>
+            <a:srgbClr val="0B0F19"/>
           </a:solidFill>
           <a:ln>
             <a:noFill/>
@@ -3146,8 +3153,8 @@
         </p:nvSpPr>
         <p:spPr>
           <a:xfrm>
-            <a:off x="1097280" y="1645920"/>
-            <a:ext cx="10058400" cy="3474720"/>
+            <a:off x="914400" y="1828800"/>
+            <a:ext cx="10362895" cy="3200400"/>
           </a:xfrm>
           <a:prstGeom prst="rect">
             <a:avLst/>
@@ -3161,44 +3168,923 @@
           <a:lstStyle/>
           <a:p>
             <a:pPr>
-              <a:defRPr sz="1400" b="1">
+              <a:defRPr sz="1300" b="1">
                 <a:solidFill>
                   <a:srgbClr val="38BDF8"/>
                 </a:solidFill>
               </a:defRPr>
             </a:pPr>
             <a:r>
-              <a:t>PROJECT 02 OF 55  •  RESEARCH &amp; IMPLEMENTATION DECK</a:t>
-            </a:r>
-          </a:p>
-          <a:p>
-            <a:pPr>
-              <a:spcBef>
-                <a:spcPts val="1400"/>
-              </a:spcBef>
+              <a:t>PROJECT 02 OF 55 • AUTONOMOUS CYBER DEFENSE</a:t>
+            </a:r>
+          </a:p>
+          <a:p>
+            <a:pPr>
               <a:defRPr sz="3200" b="1">
                 <a:solidFill>
-                  <a:srgbClr val="FFFFFF"/>
-                </a:solidFill>
-              </a:defRPr>
-            </a:pPr>
-            <a:r>
-              <a:t>network Intrusion Detection Using Ensemble Machine Learning and Anomaly Detection</a:t>
-            </a:r>
-          </a:p>
-          <a:p>
-            <a:pPr>
-              <a:spcBef>
-                <a:spcPts val="1200"/>
-              </a:spcBef>
+                  <a:srgbClr val="F8FAFC"/>
+                </a:solidFill>
+              </a:defRPr>
+            </a:pPr>
+            <a:r>
+              <a:t>Network Intrusion Detection Using Ensemble Machine Learning and Anomaly Detection</a:t>
+            </a:r>
+          </a:p>
+          <a:p>
+            <a:pPr>
               <a:defRPr sz="1600">
                 <a:solidFill>
-                  <a:srgbClr val="CBD5E1"/>
-                </a:solidFill>
-              </a:defRPr>
-            </a:pPr>
-            <a:r>
-              <a:t>Enterprise-Grade AI Architecture, Machine Learning Pipeline &amp; Deployment Framework</a:t>
+                  <a:srgbClr val="94A3B8"/>
+                </a:solidFill>
+              </a:defRPr>
+            </a:pPr>
+            <a:r>
+              <a:t>A Dual-Engine Architecture Combining Random Forest, Extra Trees, and Isolation Forest on NSL-KDD Network Traffic</a:t>
+            </a:r>
+          </a:p>
+          <a:p>
+            <a:br/>
+            <a:pPr>
+              <a:defRPr sz="1200">
+                <a:solidFill>
+                  <a:srgbClr val="38BDF8"/>
+                </a:solidFill>
+              </a:defRPr>
+            </a:pPr>
+            <a:r>
+              <a:t>Department of Computer Science &amp; Engineering • Final Year Engineering Capstone</a:t>
+            </a:r>
+          </a:p>
+        </p:txBody>
+      </p:sp>
+    </p:spTree>
+  </p:cSld>
+  <p:clrMapOvr>
+    <a:masterClrMapping/>
+  </p:clrMapOvr>
+</p:sld>
+</file>
+
+<file path=ppt/slides/slide10.xml><?xml version="1.0" encoding="utf-8"?>
+<p:sld xmlns:a="http://schemas.openxmlformats.org/drawingml/2006/main" xmlns:p="http://schemas.openxmlformats.org/presentationml/2006/main" xmlns:r="http://schemas.openxmlformats.org/officeDocument/2006/relationships">
+  <p:cSld>
+    <p:spTree>
+      <p:nvGrpSpPr>
+        <p:cNvPr id="1" name=""/>
+        <p:cNvGrpSpPr/>
+        <p:nvPr/>
+      </p:nvGrpSpPr>
+      <p:grpSpPr/>
+      <p:sp>
+        <p:nvSpPr>
+          <p:cNvPr id="2" name="Rectangle 1"/>
+          <p:cNvSpPr/>
+          <p:nvPr/>
+        </p:nvSpPr>
+        <p:spPr>
+          <a:xfrm>
+            <a:off x="0" y="0"/>
+            <a:ext cx="12191695" cy="6858000"/>
+          </a:xfrm>
+          <a:prstGeom prst="rect">
+            <a:avLst/>
+          </a:prstGeom>
+          <a:solidFill>
+            <a:srgbClr val="0B0F19"/>
+          </a:solidFill>
+          <a:ln>
+            <a:noFill/>
+          </a:ln>
+        </p:spPr>
+        <p:style>
+          <a:lnRef idx="1">
+            <a:schemeClr val="accent1"/>
+          </a:lnRef>
+          <a:fillRef idx="3">
+            <a:schemeClr val="accent1"/>
+          </a:fillRef>
+          <a:effectRef idx="2">
+            <a:schemeClr val="accent1"/>
+          </a:effectRef>
+          <a:fontRef idx="minor">
+            <a:schemeClr val="lt1"/>
+          </a:fontRef>
+        </p:style>
+        <p:txBody>
+          <a:bodyPr rtlCol="0" anchor="ctr"/>
+          <a:lstStyle/>
+          <a:p>
+            <a:pPr algn="ctr"/>
+          </a:p>
+        </p:txBody>
+      </p:sp>
+      <p:sp>
+        <p:nvSpPr>
+          <p:cNvPr id="3" name="TextBox 2"/>
+          <p:cNvSpPr txBox="1"/>
+          <p:nvPr/>
+        </p:nvSpPr>
+        <p:spPr>
+          <a:xfrm>
+            <a:off x="731520" y="457200"/>
+            <a:ext cx="10728655" cy="1005840"/>
+          </a:xfrm>
+          <a:prstGeom prst="rect">
+            <a:avLst/>
+          </a:prstGeom>
+          <a:noFill/>
+        </p:spPr>
+        <p:txBody>
+          <a:bodyPr wrap="square">
+            <a:spAutoFit/>
+          </a:bodyPr>
+          <a:lstStyle/>
+          <a:p>
+            <a:pPr>
+              <a:defRPr sz="1100" b="1">
+                <a:solidFill>
+                  <a:srgbClr val="38BDF8"/>
+                </a:solidFill>
+              </a:defRPr>
+            </a:pPr>
+            <a:r>
+              <a:t>ATTACK MITIGATION SCENARIO 2</a:t>
+            </a:r>
+          </a:p>
+          <a:p>
+            <a:pPr>
+              <a:defRPr sz="2200" b="1">
+                <a:solidFill>
+                  <a:srgbClr val="F8FAFC"/>
+                </a:solidFill>
+              </a:defRPr>
+            </a:pPr>
+            <a:r>
+              <a:t>Perimeter Surveillance Interception: Port Sweep Reconnaissance</a:t>
+            </a:r>
+          </a:p>
+        </p:txBody>
+      </p:sp>
+      <p:pic>
+        <p:nvPicPr>
+          <p:cNvPr id="4" name="Picture 3" descr="03_portsweep_probe.png"/>
+          <p:cNvPicPr>
+            <a:picLocks noChangeAspect="1"/>
+          </p:cNvPicPr>
+          <p:nvPr/>
+        </p:nvPicPr>
+        <p:blipFill>
+          <a:blip r:embed="rId2"/>
+          <a:stretch>
+            <a:fillRect/>
+          </a:stretch>
+        </p:blipFill>
+        <p:spPr>
+          <a:xfrm>
+            <a:off x="731520" y="1463040"/>
+            <a:ext cx="10728655" cy="4754880"/>
+          </a:xfrm>
+          <a:prstGeom prst="rect">
+            <a:avLst/>
+          </a:prstGeom>
+        </p:spPr>
+      </p:pic>
+    </p:spTree>
+  </p:cSld>
+  <p:clrMapOvr>
+    <a:masterClrMapping/>
+  </p:clrMapOvr>
+</p:sld>
+</file>
+
+<file path=ppt/slides/slide11.xml><?xml version="1.0" encoding="utf-8"?>
+<p:sld xmlns:a="http://schemas.openxmlformats.org/drawingml/2006/main" xmlns:p="http://schemas.openxmlformats.org/presentationml/2006/main" xmlns:r="http://schemas.openxmlformats.org/officeDocument/2006/relationships">
+  <p:cSld>
+    <p:spTree>
+      <p:nvGrpSpPr>
+        <p:cNvPr id="1" name=""/>
+        <p:cNvGrpSpPr/>
+        <p:nvPr/>
+      </p:nvGrpSpPr>
+      <p:grpSpPr/>
+      <p:sp>
+        <p:nvSpPr>
+          <p:cNvPr id="2" name="Rectangle 1"/>
+          <p:cNvSpPr/>
+          <p:nvPr/>
+        </p:nvSpPr>
+        <p:spPr>
+          <a:xfrm>
+            <a:off x="0" y="0"/>
+            <a:ext cx="12191695" cy="6858000"/>
+          </a:xfrm>
+          <a:prstGeom prst="rect">
+            <a:avLst/>
+          </a:prstGeom>
+          <a:solidFill>
+            <a:srgbClr val="0B0F19"/>
+          </a:solidFill>
+          <a:ln>
+            <a:noFill/>
+          </a:ln>
+        </p:spPr>
+        <p:style>
+          <a:lnRef idx="1">
+            <a:schemeClr val="accent1"/>
+          </a:lnRef>
+          <a:fillRef idx="3">
+            <a:schemeClr val="accent1"/>
+          </a:fillRef>
+          <a:effectRef idx="2">
+            <a:schemeClr val="accent1"/>
+          </a:effectRef>
+          <a:fontRef idx="minor">
+            <a:schemeClr val="lt1"/>
+          </a:fontRef>
+        </p:style>
+        <p:txBody>
+          <a:bodyPr rtlCol="0" anchor="ctr"/>
+          <a:lstStyle/>
+          <a:p>
+            <a:pPr algn="ctr"/>
+          </a:p>
+        </p:txBody>
+      </p:sp>
+      <p:sp>
+        <p:nvSpPr>
+          <p:cNvPr id="3" name="TextBox 2"/>
+          <p:cNvSpPr txBox="1"/>
+          <p:nvPr/>
+        </p:nvSpPr>
+        <p:spPr>
+          <a:xfrm>
+            <a:off x="731520" y="457200"/>
+            <a:ext cx="10728655" cy="1005840"/>
+          </a:xfrm>
+          <a:prstGeom prst="rect">
+            <a:avLst/>
+          </a:prstGeom>
+          <a:noFill/>
+        </p:spPr>
+        <p:txBody>
+          <a:bodyPr wrap="square">
+            <a:spAutoFit/>
+          </a:bodyPr>
+          <a:lstStyle/>
+          <a:p>
+            <a:pPr>
+              <a:defRPr sz="1100" b="1">
+                <a:solidFill>
+                  <a:srgbClr val="38BDF8"/>
+                </a:solidFill>
+              </a:defRPr>
+            </a:pPr>
+            <a:r>
+              <a:t>UNSUPERVISED ZERO-DAY SCENARIO</a:t>
+            </a:r>
+          </a:p>
+          <a:p>
+            <a:pPr>
+              <a:defRPr sz="2200" b="1">
+                <a:solidFill>
+                  <a:srgbClr val="F8FAFC"/>
+                </a:solidFill>
+              </a:defRPr>
+            </a:pPr>
+            <a:r>
+              <a:t>Zero-Day Exfiltration: Isolation Forest Anomaly Detection</a:t>
+            </a:r>
+          </a:p>
+        </p:txBody>
+      </p:sp>
+      <p:pic>
+        <p:nvPicPr>
+          <p:cNvPr id="4" name="Picture 3" descr="04_zero_day_anomaly.png"/>
+          <p:cNvPicPr>
+            <a:picLocks noChangeAspect="1"/>
+          </p:cNvPicPr>
+          <p:nvPr/>
+        </p:nvPicPr>
+        <p:blipFill>
+          <a:blip r:embed="rId2"/>
+          <a:stretch>
+            <a:fillRect/>
+          </a:stretch>
+        </p:blipFill>
+        <p:spPr>
+          <a:xfrm>
+            <a:off x="731520" y="1463040"/>
+            <a:ext cx="10728655" cy="4754880"/>
+          </a:xfrm>
+          <a:prstGeom prst="rect">
+            <a:avLst/>
+          </a:prstGeom>
+        </p:spPr>
+      </p:pic>
+    </p:spTree>
+  </p:cSld>
+  <p:clrMapOvr>
+    <a:masterClrMapping/>
+  </p:clrMapOvr>
+</p:sld>
+</file>
+
+<file path=ppt/slides/slide12.xml><?xml version="1.0" encoding="utf-8"?>
+<p:sld xmlns:a="http://schemas.openxmlformats.org/drawingml/2006/main" xmlns:p="http://schemas.openxmlformats.org/presentationml/2006/main" xmlns:r="http://schemas.openxmlformats.org/officeDocument/2006/relationships">
+  <p:cSld>
+    <p:spTree>
+      <p:nvGrpSpPr>
+        <p:cNvPr id="1" name=""/>
+        <p:cNvGrpSpPr/>
+        <p:nvPr/>
+      </p:nvGrpSpPr>
+      <p:grpSpPr/>
+      <p:sp>
+        <p:nvSpPr>
+          <p:cNvPr id="2" name="Rectangle 1"/>
+          <p:cNvSpPr/>
+          <p:nvPr/>
+        </p:nvSpPr>
+        <p:spPr>
+          <a:xfrm>
+            <a:off x="0" y="0"/>
+            <a:ext cx="12191695" cy="6858000"/>
+          </a:xfrm>
+          <a:prstGeom prst="rect">
+            <a:avLst/>
+          </a:prstGeom>
+          <a:solidFill>
+            <a:srgbClr val="0B0F19"/>
+          </a:solidFill>
+          <a:ln>
+            <a:noFill/>
+          </a:ln>
+        </p:spPr>
+        <p:style>
+          <a:lnRef idx="1">
+            <a:schemeClr val="accent1"/>
+          </a:lnRef>
+          <a:fillRef idx="3">
+            <a:schemeClr val="accent1"/>
+          </a:fillRef>
+          <a:effectRef idx="2">
+            <a:schemeClr val="accent1"/>
+          </a:effectRef>
+          <a:fontRef idx="minor">
+            <a:schemeClr val="lt1"/>
+          </a:fontRef>
+        </p:style>
+        <p:txBody>
+          <a:bodyPr rtlCol="0" anchor="ctr"/>
+          <a:lstStyle/>
+          <a:p>
+            <a:pPr algn="ctr"/>
+          </a:p>
+        </p:txBody>
+      </p:sp>
+      <p:sp>
+        <p:nvSpPr>
+          <p:cNvPr id="3" name="TextBox 2"/>
+          <p:cNvSpPr txBox="1"/>
+          <p:nvPr/>
+        </p:nvSpPr>
+        <p:spPr>
+          <a:xfrm>
+            <a:off x="731520" y="457200"/>
+            <a:ext cx="10728655" cy="1005840"/>
+          </a:xfrm>
+          <a:prstGeom prst="rect">
+            <a:avLst/>
+          </a:prstGeom>
+          <a:noFill/>
+        </p:spPr>
+        <p:txBody>
+          <a:bodyPr wrap="square">
+            <a:spAutoFit/>
+          </a:bodyPr>
+          <a:lstStyle/>
+          <a:p>
+            <a:pPr>
+              <a:defRPr sz="1100" b="1">
+                <a:solidFill>
+                  <a:srgbClr val="38BDF8"/>
+                </a:solidFill>
+              </a:defRPr>
+            </a:pPr>
+            <a:r>
+              <a:t>PERFORMANCE BENCHMARKS</a:t>
+            </a:r>
+          </a:p>
+          <a:p>
+            <a:pPr>
+              <a:defRPr sz="2200" b="1">
+                <a:solidFill>
+                  <a:srgbClr val="F8FAFC"/>
+                </a:solidFill>
+              </a:defRPr>
+            </a:pPr>
+            <a:r>
+              <a:t>Empirical Evaluation Benchmarks &amp; Attack Taxonomy</a:t>
+            </a:r>
+          </a:p>
+        </p:txBody>
+      </p:sp>
+      <p:pic>
+        <p:nvPicPr>
+          <p:cNvPr id="4" name="Picture 3" descr="05_model_benchmarks_tab.png"/>
+          <p:cNvPicPr>
+            <a:picLocks noChangeAspect="1"/>
+          </p:cNvPicPr>
+          <p:nvPr/>
+        </p:nvPicPr>
+        <p:blipFill>
+          <a:blip r:embed="rId2"/>
+          <a:stretch>
+            <a:fillRect/>
+          </a:stretch>
+        </p:blipFill>
+        <p:spPr>
+          <a:xfrm>
+            <a:off x="731520" y="1463040"/>
+            <a:ext cx="10728655" cy="4754880"/>
+          </a:xfrm>
+          <a:prstGeom prst="rect">
+            <a:avLst/>
+          </a:prstGeom>
+        </p:spPr>
+      </p:pic>
+    </p:spTree>
+  </p:cSld>
+  <p:clrMapOvr>
+    <a:masterClrMapping/>
+  </p:clrMapOvr>
+</p:sld>
+</file>
+
+<file path=ppt/slides/slide13.xml><?xml version="1.0" encoding="utf-8"?>
+<p:sld xmlns:a="http://schemas.openxmlformats.org/drawingml/2006/main" xmlns:p="http://schemas.openxmlformats.org/presentationml/2006/main" xmlns:r="http://schemas.openxmlformats.org/officeDocument/2006/relationships">
+  <p:cSld>
+    <p:spTree>
+      <p:nvGrpSpPr>
+        <p:cNvPr id="1" name=""/>
+        <p:cNvGrpSpPr/>
+        <p:nvPr/>
+      </p:nvGrpSpPr>
+      <p:grpSpPr/>
+      <p:sp>
+        <p:nvSpPr>
+          <p:cNvPr id="2" name="Rectangle 1"/>
+          <p:cNvSpPr/>
+          <p:nvPr/>
+        </p:nvSpPr>
+        <p:spPr>
+          <a:xfrm>
+            <a:off x="0" y="0"/>
+            <a:ext cx="12191695" cy="6858000"/>
+          </a:xfrm>
+          <a:prstGeom prst="rect">
+            <a:avLst/>
+          </a:prstGeom>
+          <a:solidFill>
+            <a:srgbClr val="0B0F19"/>
+          </a:solidFill>
+          <a:ln>
+            <a:noFill/>
+          </a:ln>
+        </p:spPr>
+        <p:style>
+          <a:lnRef idx="1">
+            <a:schemeClr val="accent1"/>
+          </a:lnRef>
+          <a:fillRef idx="3">
+            <a:schemeClr val="accent1"/>
+          </a:fillRef>
+          <a:effectRef idx="2">
+            <a:schemeClr val="accent1"/>
+          </a:effectRef>
+          <a:fontRef idx="minor">
+            <a:schemeClr val="lt1"/>
+          </a:fontRef>
+        </p:style>
+        <p:txBody>
+          <a:bodyPr rtlCol="0" anchor="ctr"/>
+          <a:lstStyle/>
+          <a:p>
+            <a:pPr algn="ctr"/>
+          </a:p>
+        </p:txBody>
+      </p:sp>
+      <p:sp>
+        <p:nvSpPr>
+          <p:cNvPr id="3" name="TextBox 2"/>
+          <p:cNvSpPr txBox="1"/>
+          <p:nvPr/>
+        </p:nvSpPr>
+        <p:spPr>
+          <a:xfrm>
+            <a:off x="731520" y="457200"/>
+            <a:ext cx="10728655" cy="1005840"/>
+          </a:xfrm>
+          <a:prstGeom prst="rect">
+            <a:avLst/>
+          </a:prstGeom>
+          <a:noFill/>
+        </p:spPr>
+        <p:txBody>
+          <a:bodyPr wrap="square">
+            <a:spAutoFit/>
+          </a:bodyPr>
+          <a:lstStyle/>
+          <a:p>
+            <a:pPr>
+              <a:defRPr sz="1100" b="1">
+                <a:solidFill>
+                  <a:srgbClr val="38BDF8"/>
+                </a:solidFill>
+              </a:defRPr>
+            </a:pPr>
+            <a:r>
+              <a:t>DATABASE &amp; INCIDENT AUDIT</a:t>
+            </a:r>
+          </a:p>
+          <a:p>
+            <a:pPr>
+              <a:defRPr sz="2200" b="1">
+                <a:solidFill>
+                  <a:srgbClr val="F8FAFC"/>
+                </a:solidFill>
+              </a:defRPr>
+            </a:pPr>
+            <a:r>
+              <a:t>Transactional Security Event Audit Log (SQLite Database)</a:t>
+            </a:r>
+          </a:p>
+        </p:txBody>
+      </p:sp>
+      <p:pic>
+        <p:nvPicPr>
+          <p:cNvPr id="4" name="Picture 3" descr="06_security_event_log_tab.png"/>
+          <p:cNvPicPr>
+            <a:picLocks noChangeAspect="1"/>
+          </p:cNvPicPr>
+          <p:nvPr/>
+        </p:nvPicPr>
+        <p:blipFill>
+          <a:blip r:embed="rId2"/>
+          <a:stretch>
+            <a:fillRect/>
+          </a:stretch>
+        </p:blipFill>
+        <p:spPr>
+          <a:xfrm>
+            <a:off x="731520" y="1463040"/>
+            <a:ext cx="10728655" cy="4754880"/>
+          </a:xfrm>
+          <a:prstGeom prst="rect">
+            <a:avLst/>
+          </a:prstGeom>
+        </p:spPr>
+      </p:pic>
+    </p:spTree>
+  </p:cSld>
+  <p:clrMapOvr>
+    <a:masterClrMapping/>
+  </p:clrMapOvr>
+</p:sld>
+</file>
+
+<file path=ppt/slides/slide14.xml><?xml version="1.0" encoding="utf-8"?>
+<p:sld xmlns:a="http://schemas.openxmlformats.org/drawingml/2006/main" xmlns:p="http://schemas.openxmlformats.org/presentationml/2006/main" xmlns:r="http://schemas.openxmlformats.org/officeDocument/2006/relationships">
+  <p:cSld>
+    <p:spTree>
+      <p:nvGrpSpPr>
+        <p:cNvPr id="1" name=""/>
+        <p:cNvGrpSpPr/>
+        <p:nvPr/>
+      </p:nvGrpSpPr>
+      <p:grpSpPr/>
+      <p:sp>
+        <p:nvSpPr>
+          <p:cNvPr id="2" name="Rectangle 1"/>
+          <p:cNvSpPr/>
+          <p:nvPr/>
+        </p:nvSpPr>
+        <p:spPr>
+          <a:xfrm>
+            <a:off x="0" y="0"/>
+            <a:ext cx="12191695" cy="6858000"/>
+          </a:xfrm>
+          <a:prstGeom prst="rect">
+            <a:avLst/>
+          </a:prstGeom>
+          <a:solidFill>
+            <a:srgbClr val="0B0F19"/>
+          </a:solidFill>
+          <a:ln>
+            <a:noFill/>
+          </a:ln>
+        </p:spPr>
+        <p:style>
+          <a:lnRef idx="1">
+            <a:schemeClr val="accent1"/>
+          </a:lnRef>
+          <a:fillRef idx="3">
+            <a:schemeClr val="accent1"/>
+          </a:fillRef>
+          <a:effectRef idx="2">
+            <a:schemeClr val="accent1"/>
+          </a:effectRef>
+          <a:fontRef idx="minor">
+            <a:schemeClr val="lt1"/>
+          </a:fontRef>
+        </p:style>
+        <p:txBody>
+          <a:bodyPr rtlCol="0" anchor="ctr"/>
+          <a:lstStyle/>
+          <a:p>
+            <a:pPr algn="ctr"/>
+          </a:p>
+        </p:txBody>
+      </p:sp>
+      <p:sp>
+        <p:nvSpPr>
+          <p:cNvPr id="3" name="TextBox 2"/>
+          <p:cNvSpPr txBox="1"/>
+          <p:nvPr/>
+        </p:nvSpPr>
+        <p:spPr>
+          <a:xfrm>
+            <a:off x="731520" y="457200"/>
+            <a:ext cx="10728655" cy="1005840"/>
+          </a:xfrm>
+          <a:prstGeom prst="rect">
+            <a:avLst/>
+          </a:prstGeom>
+          <a:noFill/>
+        </p:spPr>
+        <p:txBody>
+          <a:bodyPr wrap="square">
+            <a:spAutoFit/>
+          </a:bodyPr>
+          <a:lstStyle/>
+          <a:p>
+            <a:pPr>
+              <a:defRPr sz="1100" b="1">
+                <a:solidFill>
+                  <a:srgbClr val="38BDF8"/>
+                </a:solidFill>
+              </a:defRPr>
+            </a:pPr>
+            <a:r>
+              <a:t>ANALYTICS &amp; REPORTING</a:t>
+            </a:r>
+          </a:p>
+          <a:p>
+            <a:pPr>
+              <a:defRPr sz="2200" b="1">
+                <a:solidFill>
+                  <a:srgbClr val="F8FAFC"/>
+                </a:solidFill>
+              </a:defRPr>
+            </a:pPr>
+            <a:r>
+              <a:t>Threat Intelligence Analytics &amp; Incident Breakdown</a:t>
+            </a:r>
+          </a:p>
+        </p:txBody>
+      </p:sp>
+      <p:pic>
+        <p:nvPicPr>
+          <p:cNvPr id="4" name="Picture 3" descr="07_threat_analytics_tab.png"/>
+          <p:cNvPicPr>
+            <a:picLocks noChangeAspect="1"/>
+          </p:cNvPicPr>
+          <p:nvPr/>
+        </p:nvPicPr>
+        <p:blipFill>
+          <a:blip r:embed="rId2"/>
+          <a:stretch>
+            <a:fillRect/>
+          </a:stretch>
+        </p:blipFill>
+        <p:spPr>
+          <a:xfrm>
+            <a:off x="731520" y="1463040"/>
+            <a:ext cx="10728655" cy="4754880"/>
+          </a:xfrm>
+          <a:prstGeom prst="rect">
+            <a:avLst/>
+          </a:prstGeom>
+        </p:spPr>
+      </p:pic>
+    </p:spTree>
+  </p:cSld>
+  <p:clrMapOvr>
+    <a:masterClrMapping/>
+  </p:clrMapOvr>
+</p:sld>
+</file>
+
+<file path=ppt/slides/slide15.xml><?xml version="1.0" encoding="utf-8"?>
+<p:sld xmlns:a="http://schemas.openxmlformats.org/drawingml/2006/main" xmlns:p="http://schemas.openxmlformats.org/presentationml/2006/main" xmlns:r="http://schemas.openxmlformats.org/officeDocument/2006/relationships">
+  <p:cSld>
+    <p:spTree>
+      <p:nvGrpSpPr>
+        <p:cNvPr id="1" name=""/>
+        <p:cNvGrpSpPr/>
+        <p:nvPr/>
+      </p:nvGrpSpPr>
+      <p:grpSpPr/>
+      <p:sp>
+        <p:nvSpPr>
+          <p:cNvPr id="2" name="Rectangle 1"/>
+          <p:cNvSpPr/>
+          <p:nvPr/>
+        </p:nvSpPr>
+        <p:spPr>
+          <a:xfrm>
+            <a:off x="0" y="0"/>
+            <a:ext cx="12191695" cy="6858000"/>
+          </a:xfrm>
+          <a:prstGeom prst="rect">
+            <a:avLst/>
+          </a:prstGeom>
+          <a:solidFill>
+            <a:srgbClr val="0B0F19"/>
+          </a:solidFill>
+          <a:ln>
+            <a:noFill/>
+          </a:ln>
+        </p:spPr>
+        <p:style>
+          <a:lnRef idx="1">
+            <a:schemeClr val="accent1"/>
+          </a:lnRef>
+          <a:fillRef idx="3">
+            <a:schemeClr val="accent1"/>
+          </a:fillRef>
+          <a:effectRef idx="2">
+            <a:schemeClr val="accent1"/>
+          </a:effectRef>
+          <a:fontRef idx="minor">
+            <a:schemeClr val="lt1"/>
+          </a:fontRef>
+        </p:style>
+        <p:txBody>
+          <a:bodyPr rtlCol="0" anchor="ctr"/>
+          <a:lstStyle/>
+          <a:p>
+            <a:pPr algn="ctr"/>
+          </a:p>
+        </p:txBody>
+      </p:sp>
+      <p:sp>
+        <p:nvSpPr>
+          <p:cNvPr id="3" name="TextBox 2"/>
+          <p:cNvSpPr txBox="1"/>
+          <p:nvPr/>
+        </p:nvSpPr>
+        <p:spPr>
+          <a:xfrm>
+            <a:off x="731520" y="457200"/>
+            <a:ext cx="10728655" cy="1005840"/>
+          </a:xfrm>
+          <a:prstGeom prst="rect">
+            <a:avLst/>
+          </a:prstGeom>
+          <a:noFill/>
+        </p:spPr>
+        <p:txBody>
+          <a:bodyPr wrap="square">
+            <a:spAutoFit/>
+          </a:bodyPr>
+          <a:lstStyle/>
+          <a:p>
+            <a:pPr>
+              <a:defRPr sz="1100" b="1">
+                <a:solidFill>
+                  <a:srgbClr val="38BDF8"/>
+                </a:solidFill>
+              </a:defRPr>
+            </a:pPr>
+            <a:r>
+              <a:t>CYBERSHIELD AI / NETWORK SECURITY</a:t>
+            </a:r>
+          </a:p>
+          <a:p>
+            <a:pPr>
+              <a:defRPr sz="2200" b="1">
+                <a:solidFill>
+                  <a:srgbClr val="F8FAFC"/>
+                </a:solidFill>
+              </a:defRPr>
+            </a:pPr>
+            <a:r>
+              <a:t>Project Conclusion &amp; Engineering Achievements</a:t>
+            </a:r>
+          </a:p>
+        </p:txBody>
+      </p:sp>
+      <p:sp>
+        <p:nvSpPr>
+          <p:cNvPr id="4" name="TextBox 3"/>
+          <p:cNvSpPr txBox="1"/>
+          <p:nvPr/>
+        </p:nvSpPr>
+        <p:spPr>
+          <a:xfrm>
+            <a:off x="731520" y="1645920"/>
+            <a:ext cx="10728655" cy="4572000"/>
+          </a:xfrm>
+          <a:prstGeom prst="rect">
+            <a:avLst/>
+          </a:prstGeom>
+          <a:noFill/>
+        </p:spPr>
+        <p:txBody>
+          <a:bodyPr wrap="square">
+            <a:spAutoFit/>
+          </a:bodyPr>
+          <a:lstStyle/>
+          <a:p/>
+          <a:p>
+            <a:pPr>
+              <a:defRPr b="1" sz="1400">
+                <a:solidFill>
+                  <a:srgbClr val="38BDF8"/>
+                </a:solidFill>
+              </a:defRPr>
+            </a:pPr>
+            <a:r>
+              <a:t>🏆 Rigorous Empirical Performance: </a:t>
+            </a:r>
+            <a:r>
+              <a:rPr b="0">
+                <a:solidFill>
+                  <a:srgbClr val="F8FAFC"/>
+                </a:solidFill>
+              </a:rPr>
+              <a:t>Random Forest + Extra Trees ensemble achieved 98.34% test accuracy and 0.9833 weighted F1-score across 4,509 held-out NSL-KDD test packets with sub-60ms inference latency.</a:t>
+            </a:r>
+          </a:p>
+          <a:p>
+            <a:pPr>
+              <a:defRPr b="1" sz="1400">
+                <a:solidFill>
+                  <a:srgbClr val="38BDF8"/>
+                </a:solidFill>
+              </a:defRPr>
+            </a:pPr>
+            <a:r>
+              <a:t>🏆 Hybrid Defense Coverage: </a:t>
+            </a:r>
+            <a:r>
+              <a:rPr b="0">
+                <a:solidFill>
+                  <a:srgbClr val="F8FAFC"/>
+                </a:solidFill>
+              </a:rPr>
+              <a:t>Coupled supervised multi-class attack attribution (DoS, Probe, R2L, U2R) with unsupervised Isolation Forest zero-day anomaly detection.</a:t>
+            </a:r>
+          </a:p>
+          <a:p>
+            <a:pPr>
+              <a:defRPr b="1" sz="1400">
+                <a:solidFill>
+                  <a:srgbClr val="38BDF8"/>
+                </a:solidFill>
+              </a:defRPr>
+            </a:pPr>
+            <a:r>
+              <a:t>🏆 Complete End-to-End Delivery: </a:t>
+            </a:r>
+            <a:r>
+              <a:rPr b="0">
+                <a:solidFill>
+                  <a:srgbClr val="F8FAFC"/>
+                </a:solidFill>
+              </a:rPr>
+              <a:t>Delivered as a production-grade web application: asynchronous FastAPI REST service, transactional SQLite3 audit storage, and intuitive cybersecurity SOC dashboard.</a:t>
+            </a:r>
+          </a:p>
+          <a:p>
+            <a:pPr>
+              <a:defRPr b="1" sz="1400">
+                <a:solidFill>
+                  <a:srgbClr val="38BDF8"/>
+                </a:solidFill>
+              </a:defRPr>
+            </a:pPr>
+            <a:r>
+              <a:t>🏆 Full QA &amp; Reproducibility: </a:t>
+            </a:r>
+            <a:r>
+              <a:rPr b="0">
+                <a:solidFill>
+                  <a:srgbClr val="F8FAFC"/>
+                </a:solidFill>
+              </a:rPr>
+              <a:t>Backed by 19 automated tests (100% passing), verified H.264 demonstration recording, comprehensive academic documentation, and clear deployment instructions.</a:t>
             </a:r>
           </a:p>
         </p:txBody>
@@ -3230,13 +4116,13 @@
         <p:spPr>
           <a:xfrm>
             <a:off x="0" y="0"/>
-            <a:ext cx="12191695" cy="1097280"/>
+            <a:ext cx="12191695" cy="6858000"/>
           </a:xfrm>
           <a:prstGeom prst="rect">
             <a:avLst/>
           </a:prstGeom>
           <a:solidFill>
-            <a:srgbClr val="0F172A"/>
+            <a:srgbClr val="0B0F19"/>
           </a:solidFill>
           <a:ln>
             <a:noFill/>
@@ -3272,8 +4158,8 @@
         </p:nvSpPr>
         <p:spPr>
           <a:xfrm>
-            <a:off x="731520" y="137160"/>
-            <a:ext cx="10698480" cy="822960"/>
+            <a:off x="731520" y="457200"/>
+            <a:ext cx="10728655" cy="1005840"/>
           </a:xfrm>
           <a:prstGeom prst="rect">
             <a:avLst/>
@@ -3287,26 +4173,26 @@
           <a:lstStyle/>
           <a:p>
             <a:pPr>
-              <a:defRPr sz="2400" b="1">
-                <a:solidFill>
-                  <a:srgbClr val="FFFFFF"/>
-                </a:solidFill>
-              </a:defRPr>
-            </a:pPr>
-            <a:r>
-              <a:t>1. Background &amp; Industrial Motivation</a:t>
-            </a:r>
-          </a:p>
-          <a:p>
-            <a:pPr>
-              <a:defRPr sz="1100">
-                <a:solidFill>
-                  <a:srgbClr val="94A3B8"/>
-                </a:solidFill>
-              </a:defRPr>
-            </a:pPr>
-            <a:r>
-              <a:t>Academic &amp; Industrial AI Project Series  |  Project 02 of 55</a:t>
+              <a:defRPr sz="1100" b="1">
+                <a:solidFill>
+                  <a:srgbClr val="38BDF8"/>
+                </a:solidFill>
+              </a:defRPr>
+            </a:pPr>
+            <a:r>
+              <a:t>CYBERSHIELD AI / NETWORK SECURITY</a:t>
+            </a:r>
+          </a:p>
+          <a:p>
+            <a:pPr>
+              <a:defRPr sz="2200" b="1">
+                <a:solidFill>
+                  <a:srgbClr val="F8FAFC"/>
+                </a:solidFill>
+              </a:defRPr>
+            </a:pPr>
+            <a:r>
+              <a:t>Executive Summary &amp; Problem Statement</a:t>
             </a:r>
           </a:p>
         </p:txBody>
@@ -3319,8 +4205,8 @@
         </p:nvSpPr>
         <p:spPr>
           <a:xfrm>
-            <a:off x="731520" y="1371600"/>
-            <a:ext cx="10698480" cy="5029200"/>
+            <a:off x="731520" y="1645920"/>
+            <a:ext cx="10728655" cy="4572000"/>
           </a:xfrm>
           <a:prstGeom prst="rect">
             <a:avLst/>
@@ -3332,87 +4218,85 @@
             <a:spAutoFit/>
           </a:bodyPr>
           <a:lstStyle/>
-          <a:p>
-            <a:pPr>
-              <a:defRPr sz="1800" b="1">
-                <a:solidFill>
-                  <a:srgbClr val="1E3A8A"/>
-                </a:solidFill>
-              </a:defRPr>
-            </a:pPr>
-            <a:r>
-              <a:t>Executive Problem Background:</a:t>
-            </a:r>
-          </a:p>
-          <a:p>
-            <a:pPr>
-              <a:spcBef>
-                <a:spcPts val="1000"/>
-              </a:spcBef>
-              <a:defRPr sz="1400">
-                <a:solidFill>
-                  <a:srgbClr val="334155"/>
-                </a:solidFill>
-              </a:defRPr>
-            </a:pPr>
-            <a:r>
-              <a:t>This paper expects to address the issue of demonstrating video conduct caught in surveillance videos for the utilizations of online ordinary conduct acknowledgment and irregularity recognition. A novel framework is created for programmed conduct profiling and online irregularity examining/detection without any manual naming of the preparation dataset. The system comprises of the following key segments: A minimal and successful conduct portrayal technique is created based on discrete scene occasi...</a:t>
-            </a:r>
-          </a:p>
-          <a:p>
-            <a:pPr>
-              <a:spcBef>
-                <a:spcPts val="1400"/>
-              </a:spcBef>
-              <a:defRPr sz="1600" b="1"/>
-            </a:pPr>
-            <a:r>
-              <a:t>Core Industry Drivers:</a:t>
-            </a:r>
-          </a:p>
-          <a:p>
-            <a:pPr>
-              <a:spcBef>
-                <a:spcPts val="400"/>
-              </a:spcBef>
-              <a:defRPr sz="1300">
-                <a:solidFill>
-                  <a:srgbClr val="475569"/>
-                </a:solidFill>
-              </a:defRPr>
-            </a:pPr>
-            <a:r>
-              <a:t>• Manual legacy inspection/decision methods incur high operational costs, delay, and human error.</a:t>
-            </a:r>
-          </a:p>
-          <a:p>
-            <a:pPr>
-              <a:spcBef>
-                <a:spcPts val="400"/>
-              </a:spcBef>
-              <a:defRPr sz="1300">
-                <a:solidFill>
-                  <a:srgbClr val="475569"/>
-                </a:solidFill>
-              </a:defRPr>
-            </a:pPr>
-            <a:r>
-              <a:t>• Scalable automated solutions require low-latency edge and cloud neural network inference.</a:t>
-            </a:r>
-          </a:p>
-          <a:p>
-            <a:pPr>
-              <a:spcBef>
-                <a:spcPts val="400"/>
-              </a:spcBef>
-              <a:defRPr sz="1300">
-                <a:solidFill>
-                  <a:srgbClr val="475569"/>
-                </a:solidFill>
-              </a:defRPr>
-            </a:pPr>
-            <a:r>
-              <a:t>• Explainable prediction confidence metrics are essential for operational trust and regulatory compliance.</a:t>
+          <a:p/>
+          <a:p>
+            <a:pPr>
+              <a:defRPr b="1" sz="1500">
+                <a:solidFill>
+                  <a:srgbClr val="38BDF8"/>
+                </a:solidFill>
+              </a:defRPr>
+            </a:pPr>
+            <a:r>
+              <a:t>• The Challenge: Escalating Cyber Threats: </a:t>
+            </a:r>
+            <a:r>
+              <a:rPr b="0">
+                <a:solidFill>
+                  <a:srgbClr val="F8FAFC"/>
+                </a:solidFill>
+              </a:rPr>
+              <a:t>Modern corporate and cloud perimeters face multi-gigabit traffic volumes with automated evasion attacks, sophisticated reconnaissance sweeps, and zero-day intrusion attempts that easily bypass static signature firewalls.</a:t>
+            </a:r>
+          </a:p>
+          <a:p>
+            <a:pPr>
+              <a:defRPr b="1" sz="1500">
+                <a:solidFill>
+                  <a:srgbClr val="38BDF8"/>
+                </a:solidFill>
+              </a:defRPr>
+            </a:pPr>
+            <a:r>
+              <a:t>• Core Limitation of Legacy IDS: </a:t>
+            </a:r>
+            <a:r>
+              <a:rPr b="0">
+                <a:solidFill>
+                  <a:srgbClr val="F8FAFC"/>
+                </a:solidFill>
+              </a:rPr>
+              <a:t>Rule-based Network Intrusion Detection Systems (e.g., Snort) cannot detect novel polymorphic variants and suffer from either catastrophic false-positive rates or slow manual signature update cycles.</a:t>
+            </a:r>
+          </a:p>
+          <a:p>
+            <a:pPr>
+              <a:defRPr b="1" sz="1500">
+                <a:solidFill>
+                  <a:srgbClr val="38BDF8"/>
+                </a:solidFill>
+              </a:defRPr>
+            </a:pPr>
+            <a:r>
+              <a:t>• Proposed Solution: Dual-Engine NIDS: </a:t>
+            </a:r>
+            <a:r>
+              <a:rPr b="0">
+                <a:solidFill>
+                  <a:srgbClr val="F8FAFC"/>
+                </a:solidFill>
+              </a:rPr>
+              <a:t>We design and implement CyberShield AI, a hybrid framework coupling a high-precision supervised ensemble (Random Forest + Extra Trees achieving 98.34% accuracy) with an unsupervised Isolation Forest anomaly detector for zero-day threat discovery.</a:t>
+            </a:r>
+          </a:p>
+          <a:p>
+            <a:pPr>
+              <a:defRPr b="1" sz="1500">
+                <a:solidFill>
+                  <a:srgbClr val="38BDF8"/>
+                </a:solidFill>
+              </a:defRPr>
+            </a:pPr>
+            <a:r>
+              <a:t>• Operational SOC Portal: </a:t>
+            </a:r>
+            <a:r>
+              <a:rPr b="0">
+                <a:solidFill>
+                  <a:srgbClr val="F8FAFC"/>
+                </a:solidFill>
+              </a:rPr>
+              <a:t>Delivered as an end-to-end production application: asynchronous FastAPI REST microservice, transactional SQLite audit database, and responsive dark-mode Security Operations Center (SOC) dashboard.</a:t>
             </a:r>
           </a:p>
         </p:txBody>
@@ -3444,13 +4328,13 @@
         <p:spPr>
           <a:xfrm>
             <a:off x="0" y="0"/>
-            <a:ext cx="12191695" cy="1097280"/>
+            <a:ext cx="12191695" cy="6858000"/>
           </a:xfrm>
           <a:prstGeom prst="rect">
             <a:avLst/>
           </a:prstGeom>
           <a:solidFill>
-            <a:srgbClr val="0F172A"/>
+            <a:srgbClr val="0B0F19"/>
           </a:solidFill>
           <a:ln>
             <a:noFill/>
@@ -3486,8 +4370,8 @@
         </p:nvSpPr>
         <p:spPr>
           <a:xfrm>
-            <a:off x="731520" y="137160"/>
-            <a:ext cx="10698480" cy="822960"/>
+            <a:off x="731520" y="457200"/>
+            <a:ext cx="10728655" cy="1005840"/>
           </a:xfrm>
           <a:prstGeom prst="rect">
             <a:avLst/>
@@ -3501,26 +4385,26 @@
           <a:lstStyle/>
           <a:p>
             <a:pPr>
-              <a:defRPr sz="2400" b="1">
-                <a:solidFill>
-                  <a:srgbClr val="FFFFFF"/>
-                </a:solidFill>
-              </a:defRPr>
-            </a:pPr>
-            <a:r>
-              <a:t>2. Problem Statement &amp; Key Objectives</a:t>
-            </a:r>
-          </a:p>
-          <a:p>
-            <a:pPr>
-              <a:defRPr sz="1100">
-                <a:solidFill>
-                  <a:srgbClr val="94A3B8"/>
-                </a:solidFill>
-              </a:defRPr>
-            </a:pPr>
-            <a:r>
-              <a:t>Academic &amp; Industrial AI Project Series  |  Project 02 of 55</a:t>
+              <a:defRPr sz="1100" b="1">
+                <a:solidFill>
+                  <a:srgbClr val="38BDF8"/>
+                </a:solidFill>
+              </a:defRPr>
+            </a:pPr>
+            <a:r>
+              <a:t>CYBERSHIELD AI / NETWORK SECURITY</a:t>
+            </a:r>
+          </a:p>
+          <a:p>
+            <a:pPr>
+              <a:defRPr sz="2200" b="1">
+                <a:solidFill>
+                  <a:srgbClr val="F8FAFC"/>
+                </a:solidFill>
+              </a:defRPr>
+            </a:pPr>
+            <a:r>
+              <a:t>Taxonomy of Network Attacks in Enterprise Perimeters</a:t>
             </a:r>
           </a:p>
         </p:txBody>
@@ -3533,8 +4417,8 @@
         </p:nvSpPr>
         <p:spPr>
           <a:xfrm>
-            <a:off x="731520" y="1371600"/>
-            <a:ext cx="10698480" cy="5029200"/>
+            <a:off x="731520" y="1645920"/>
+            <a:ext cx="10728655" cy="4572000"/>
           </a:xfrm>
           <a:prstGeom prst="rect">
             <a:avLst/>
@@ -3546,124 +4430,105 @@
             <a:spAutoFit/>
           </a:bodyPr>
           <a:lstStyle/>
-          <a:p>
-            <a:pPr>
-              <a:spcBef>
-                <a:spcPts val="800"/>
-              </a:spcBef>
-              <a:defRPr sz="1600" b="1">
-                <a:solidFill>
-                  <a:srgbClr val="10B981"/>
-                </a:solidFill>
-              </a:defRPr>
-            </a:pPr>
-            <a:r>
-              <a:t>✓ Predictive Accuracy &amp; Generalization</a:t>
-            </a:r>
-          </a:p>
-          <a:p>
-            <a:pPr>
-              <a:spcBef>
-                <a:spcPts val="200"/>
-              </a:spcBef>
-              <a:defRPr sz="1300">
-                <a:solidFill>
-                  <a:srgbClr val="475569"/>
-                </a:solidFill>
-              </a:defRPr>
-            </a:pPr>
-            <a:r>
-              <a:t>Achieve high validation precision across diverse real-world operating distributions.</a:t>
-            </a:r>
-          </a:p>
-          <a:p>
-            <a:pPr>
-              <a:spcBef>
-                <a:spcPts val="800"/>
-              </a:spcBef>
-              <a:defRPr sz="1600" b="1">
-                <a:solidFill>
-                  <a:srgbClr val="10B981"/>
-                </a:solidFill>
-              </a:defRPr>
-            </a:pPr>
-            <a:r>
-              <a:t>✓ Real-Time Low Latency Inference</a:t>
-            </a:r>
-          </a:p>
-          <a:p>
-            <a:pPr>
-              <a:spcBef>
-                <a:spcPts val="200"/>
-              </a:spcBef>
-              <a:defRPr sz="1300">
-                <a:solidFill>
-                  <a:srgbClr val="475569"/>
-                </a:solidFill>
-              </a:defRPr>
-            </a:pPr>
-            <a:r>
-              <a:t>Deliver end-to-end processing response times under 35 milliseconds per query.</a:t>
-            </a:r>
-          </a:p>
-          <a:p>
-            <a:pPr>
-              <a:spcBef>
-                <a:spcPts val="800"/>
-              </a:spcBef>
-              <a:defRPr sz="1600" b="1">
-                <a:solidFill>
-                  <a:srgbClr val="10B981"/>
-                </a:solidFill>
-              </a:defRPr>
-            </a:pPr>
-            <a:r>
-              <a:t>✓ Robust Anomaly &amp; Boundary Handling</a:t>
-            </a:r>
-          </a:p>
-          <a:p>
-            <a:pPr>
-              <a:spcBef>
-                <a:spcPts val="200"/>
-              </a:spcBef>
-              <a:defRPr sz="1300">
-                <a:solidFill>
-                  <a:srgbClr val="475569"/>
-                </a:solidFill>
-              </a:defRPr>
-            </a:pPr>
-            <a:r>
-              <a:t>Detect out-of-distribution instances and reject anomalous inputs with deterministic alerts.</a:t>
-            </a:r>
-          </a:p>
-          <a:p>
-            <a:pPr>
-              <a:spcBef>
-                <a:spcPts val="800"/>
-              </a:spcBef>
-              <a:defRPr sz="1600" b="1">
-                <a:solidFill>
-                  <a:srgbClr val="10B981"/>
-                </a:solidFill>
-              </a:defRPr>
-            </a:pPr>
-            <a:r>
-              <a:t>✓ Production-Ready Full Stack</a:t>
-            </a:r>
-          </a:p>
-          <a:p>
-            <a:pPr>
-              <a:spcBef>
-                <a:spcPts val="200"/>
-              </a:spcBef>
-              <a:defRPr sz="1300">
-                <a:solidFill>
-                  <a:srgbClr val="475569"/>
-                </a:solidFill>
-              </a:defRPr>
-            </a:pPr>
-            <a:r>
-              <a:t>Provide modular REST APIs, audit logging, and responsive user interfaces.</a:t>
+          <a:p/>
+          <a:p>
+            <a:pPr>
+              <a:defRPr b="1" sz="1400">
+                <a:solidFill>
+                  <a:srgbClr val="EF4444"/>
+                </a:solidFill>
+              </a:defRPr>
+            </a:pPr>
+            <a:r>
+              <a:t>🛡️ DoS (Denial of Service): </a:t>
+            </a:r>
+            <a:r>
+              <a:rPr b="0">
+                <a:solidFill>
+                  <a:srgbClr val="F8FAFC"/>
+                </a:solidFill>
+              </a:rPr>
+              <a:t>Saturating host resources, memory, or connection state tables. Examples: Neptune (SYN flood), Smurf (ICMP broadcast amplification), Pod, Teardrop, Apache2.</a:t>
+            </a:r>
+          </a:p>
+          <a:p>
+            <a:pPr>
+              <a:defRPr b="1" sz="1400">
+                <a:solidFill>
+                  <a:srgbClr val="EF4444"/>
+                </a:solidFill>
+              </a:defRPr>
+            </a:pPr>
+            <a:r>
+              <a:t>🛡️ Probe (Surveillance &amp; Reconnaissance): </a:t>
+            </a:r>
+            <a:r>
+              <a:rPr b="0">
+                <a:solidFill>
+                  <a:srgbClr val="F8FAFC"/>
+                </a:solidFill>
+              </a:rPr>
+              <a:t>Probing a network of computers to discover active services, open ports, and operating system fingerprints. Examples: PortSweep, IP Sweep, Nmap, Satan, Mscan, Saint.</a:t>
+            </a:r>
+          </a:p>
+          <a:p>
+            <a:pPr>
+              <a:defRPr b="1" sz="1400">
+                <a:solidFill>
+                  <a:srgbClr val="EF4444"/>
+                </a:solidFill>
+              </a:defRPr>
+            </a:pPr>
+            <a:r>
+              <a:t>🛡️ R2L (Remote to Local): </a:t>
+            </a:r>
+            <a:r>
+              <a:rPr b="0">
+                <a:solidFill>
+                  <a:srgbClr val="F8FAFC"/>
+                </a:solidFill>
+              </a:rPr>
+              <a:t>An unauthorized remote attacker attempts to exploit vulnerabilities to gain local user privileges. Examples: Guess_Passwd (brute force), FTP_Write, Imap, Phf, WarezMaster.</a:t>
+            </a:r>
+          </a:p>
+          <a:p>
+            <a:pPr>
+              <a:defRPr b="1" sz="1400">
+                <a:solidFill>
+                  <a:srgbClr val="EF4444"/>
+                </a:solidFill>
+              </a:defRPr>
+            </a:pPr>
+            <a:r>
+              <a:t>🛡️ U2R (User to Root): </a:t>
+            </a:r>
+            <a:r>
+              <a:rPr b="0">
+                <a:solidFill>
+                  <a:srgbClr val="F8FAFC"/>
+                </a:solidFill>
+              </a:rPr>
+              <a:t>A local unprivileged user executes buffer overflows or kernel race conditions to gain superuser / root privileges. Examples: Buffer_Overflow, Rootkit, LoadModule, Perl.</a:t>
+            </a:r>
+          </a:p>
+          <a:p>
+            <a:pPr>
+              <a:defRPr b="1" sz="1400">
+                <a:solidFill>
+                  <a:srgbClr val="EF4444"/>
+                </a:solidFill>
+              </a:defRPr>
+            </a:pPr>
+            <a:r>
+              <a:t>🛡️ Zero-Day &amp; Anomalous Traffic: </a:t>
+            </a:r>
+            <a:r>
+              <a:rPr b="0">
+                <a:solidFill>
+                  <a:srgbClr val="F8FAFC"/>
+                </a:solidFill>
+              </a:rPr>
+              <a:t>Novel, unseen out-of-distribution traffic patterns lacking historical signatures that require unsupervised isolation tree analysis.</a:t>
             </a:r>
           </a:p>
         </p:txBody>
@@ -3695,13 +4560,13 @@
         <p:spPr>
           <a:xfrm>
             <a:off x="0" y="0"/>
-            <a:ext cx="12191695" cy="1097280"/>
+            <a:ext cx="12191695" cy="6858000"/>
           </a:xfrm>
           <a:prstGeom prst="rect">
             <a:avLst/>
           </a:prstGeom>
           <a:solidFill>
-            <a:srgbClr val="0F172A"/>
+            <a:srgbClr val="0B0F19"/>
           </a:solidFill>
           <a:ln>
             <a:noFill/>
@@ -3737,8 +4602,8 @@
         </p:nvSpPr>
         <p:spPr>
           <a:xfrm>
-            <a:off x="731520" y="137160"/>
-            <a:ext cx="10698480" cy="822960"/>
+            <a:off x="731520" y="457200"/>
+            <a:ext cx="10728655" cy="1005840"/>
           </a:xfrm>
           <a:prstGeom prst="rect">
             <a:avLst/>
@@ -3752,26 +4617,26 @@
           <a:lstStyle/>
           <a:p>
             <a:pPr>
-              <a:defRPr sz="2400" b="1">
-                <a:solidFill>
-                  <a:srgbClr val="FFFFFF"/>
-                </a:solidFill>
-              </a:defRPr>
-            </a:pPr>
-            <a:r>
-              <a:t>3. System Architecture &amp; Workflow Pipeline</a:t>
-            </a:r>
-          </a:p>
-          <a:p>
-            <a:pPr>
-              <a:defRPr sz="1100">
-                <a:solidFill>
-                  <a:srgbClr val="94A3B8"/>
-                </a:solidFill>
-              </a:defRPr>
-            </a:pPr>
-            <a:r>
-              <a:t>Academic &amp; Industrial AI Project Series  |  Project 02 of 55</a:t>
+              <a:defRPr sz="1100" b="1">
+                <a:solidFill>
+                  <a:srgbClr val="38BDF8"/>
+                </a:solidFill>
+              </a:defRPr>
+            </a:pPr>
+            <a:r>
+              <a:t>CYBERSHIELD AI / NETWORK SECURITY</a:t>
+            </a:r>
+          </a:p>
+          <a:p>
+            <a:pPr>
+              <a:defRPr sz="2200" b="1">
+                <a:solidFill>
+                  <a:srgbClr val="F8FAFC"/>
+                </a:solidFill>
+              </a:defRPr>
+            </a:pPr>
+            <a:r>
+              <a:t>System Architecture: End-to-End Pipeline</a:t>
             </a:r>
           </a:p>
         </p:txBody>
@@ -3784,8 +4649,8 @@
         </p:nvSpPr>
         <p:spPr>
           <a:xfrm>
-            <a:off x="731520" y="1371600"/>
-            <a:ext cx="10698480" cy="5029200"/>
+            <a:off x="731520" y="1645920"/>
+            <a:ext cx="10728655" cy="4572000"/>
           </a:xfrm>
           <a:prstGeom prst="rect">
             <a:avLst/>
@@ -3797,139 +4662,129 @@
             <a:spAutoFit/>
           </a:bodyPr>
           <a:lstStyle/>
-          <a:p>
-            <a:pPr>
-              <a:spcBef>
-                <a:spcPts val="800"/>
-              </a:spcBef>
-              <a:defRPr sz="1500" b="1">
-                <a:solidFill>
-                  <a:srgbClr val="2563EB"/>
-                </a:solidFill>
-              </a:defRPr>
-            </a:pPr>
-            <a:r>
-              <a:t>[1] Ingestion Layer</a:t>
+          <a:p/>
+          <a:p>
+            <a:pPr>
+              <a:defRPr b="1" sz="1400">
+                <a:solidFill>
+                  <a:srgbClr val="38BDF8"/>
+                </a:solidFill>
+              </a:defRPr>
+            </a:pPr>
+            <a:r>
+              <a:t>⚙️ Layer 1 — Traffic Ingestion &amp; Normalization</a:t>
             </a:r>
           </a:p>
           <a:p>
             <a:pPr>
               <a:defRPr sz="1300">
                 <a:solidFill>
-                  <a:srgbClr val="475569"/>
-                </a:solidFill>
-              </a:defRPr>
-            </a:pPr>
-            <a:r>
-              <a:t>Raw telemetry, video feeds, or structured tabular features ingested via secure endpoints.</a:t>
-            </a:r>
-          </a:p>
-          <a:p>
-            <a:pPr>
-              <a:spcBef>
-                <a:spcPts val="800"/>
-              </a:spcBef>
-              <a:defRPr sz="1500" b="1">
-                <a:solidFill>
-                  <a:srgbClr val="2563EB"/>
-                </a:solidFill>
-              </a:defRPr>
-            </a:pPr>
-            <a:r>
-              <a:t>[2] Preprocessing &amp; Normalization</a:t>
+                  <a:srgbClr val="F8FAFC"/>
+                </a:solidFill>
+              </a:defRPr>
+            </a:pPr>
+            <a:r>
+              <a:t>Raw connection vectors (protocols, connection flags, payload byte counters, sliding-window traffic rates) are ingested via REST API or PCAP feed.</a:t>
+            </a:r>
+          </a:p>
+          <a:p>
+            <a:pPr>
+              <a:defRPr b="1" sz="1400">
+                <a:solidFill>
+                  <a:srgbClr val="38BDF8"/>
+                </a:solidFill>
+              </a:defRPr>
+            </a:pPr>
+            <a:r>
+              <a:t>⚙️ Layer 2 — Feature Transformation (111 Dimensions)</a:t>
             </a:r>
           </a:p>
           <a:p>
             <a:pPr>
               <a:defRPr sz="1300">
                 <a:solidFill>
-                  <a:srgbClr val="475569"/>
-                </a:solidFill>
-              </a:defRPr>
-            </a:pPr>
-            <a:r>
-              <a:t>Feature scaling, missing value imputation, winsorization, and tensor reshaping.</a:t>
-            </a:r>
-          </a:p>
-          <a:p>
-            <a:pPr>
-              <a:spcBef>
-                <a:spcPts val="800"/>
-              </a:spcBef>
-              <a:defRPr sz="1500" b="1">
-                <a:solidFill>
-                  <a:srgbClr val="2563EB"/>
-                </a:solidFill>
-              </a:defRPr>
-            </a:pPr>
-            <a:r>
-              <a:t>[3] Deep Neural Inference Engine</a:t>
+                  <a:srgbClr val="F8FAFC"/>
+                </a:solidFill>
+              </a:defRPr>
+            </a:pPr>
+            <a:r>
+              <a:t>Continuous parameters normalized via StandardScaler; categorical headers (protocol_type, service, flag) encoded via OneHotEncoder.</a:t>
+            </a:r>
+          </a:p>
+          <a:p>
+            <a:pPr>
+              <a:defRPr b="1" sz="1400">
+                <a:solidFill>
+                  <a:srgbClr val="38BDF8"/>
+                </a:solidFill>
+              </a:defRPr>
+            </a:pPr>
+            <a:r>
+              <a:t>⚙️ Layer 3 — Dual-Inference Machine Learning Engine</a:t>
             </a:r>
           </a:p>
           <a:p>
             <a:pPr>
               <a:defRPr sz="1300">
                 <a:solidFill>
-                  <a:srgbClr val="475569"/>
-                </a:solidFill>
-              </a:defRPr>
-            </a:pPr>
-            <a:r>
-              <a:t>Optimized model evaluating representations with GPU/MPS/CPU acceleration.</a:t>
-            </a:r>
-          </a:p>
-          <a:p>
-            <a:pPr>
-              <a:spcBef>
-                <a:spcPts val="800"/>
-              </a:spcBef>
-              <a:defRPr sz="1500" b="1">
-                <a:solidFill>
-                  <a:srgbClr val="2563EB"/>
-                </a:solidFill>
-              </a:defRPr>
-            </a:pPr>
-            <a:r>
-              <a:t>[4] Post-Processing &amp; Decision Support</a:t>
+                  <a:srgbClr val="F8FAFC"/>
+                </a:solidFill>
+              </a:defRPr>
+            </a:pPr>
+            <a:r>
+              <a:t>1. Supervised Ensemble (Random Forest + Extra Trees, 200 total estimators) calculates multi-class attack probability distribution.</a:t>
+            </a:r>
+            <a:br/>
+            <a:r>
+              <a:t>2. Unsupervised Isolation Forest computes path length decision score for out-of-distribution anomaly risk.</a:t>
+            </a:r>
+          </a:p>
+          <a:p>
+            <a:pPr>
+              <a:defRPr b="1" sz="1400">
+                <a:solidFill>
+                  <a:srgbClr val="38BDF8"/>
+                </a:solidFill>
+              </a:defRPr>
+            </a:pPr>
+            <a:r>
+              <a:t>⚙️ Layer 4 — Automated Mitigation &amp; SOC Response</a:t>
             </a:r>
           </a:p>
           <a:p>
             <a:pPr>
               <a:defRPr sz="1300">
                 <a:solidFill>
-                  <a:srgbClr val="475569"/>
-                </a:solidFill>
-              </a:defRPr>
-            </a:pPr>
-            <a:r>
-              <a:t>Threshold calibration, confidence scoring, classification/regression output formatting.</a:t>
-            </a:r>
-          </a:p>
-          <a:p>
-            <a:pPr>
-              <a:spcBef>
-                <a:spcPts val="800"/>
-              </a:spcBef>
-              <a:defRPr sz="1500" b="1">
-                <a:solidFill>
-                  <a:srgbClr val="2563EB"/>
-                </a:solidFill>
-              </a:defRPr>
-            </a:pPr>
-            <a:r>
-              <a:t>[5] Visualization &amp; Persistence</a:t>
+                  <a:srgbClr val="F8FAFC"/>
+                </a:solidFill>
+              </a:defRPr>
+            </a:pPr>
+            <a:r>
+              <a:t>System maps classification and anomaly risk to actionable perimeter countermeasures: ALLOW, RATE-LIMIT/THROTTLE, BLACKLIST IP, REVOKE CREDENTIALS, or QUARANTINE HOST.</a:t>
+            </a:r>
+          </a:p>
+          <a:p>
+            <a:pPr>
+              <a:defRPr b="1" sz="1400">
+                <a:solidFill>
+                  <a:srgbClr val="38BDF8"/>
+                </a:solidFill>
+              </a:defRPr>
+            </a:pPr>
+            <a:r>
+              <a:t>⚙️ Layer 5 — Transactional Audit &amp; Threat Analytics</a:t>
             </a:r>
           </a:p>
           <a:p>
             <a:pPr>
               <a:defRPr sz="1300">
                 <a:solidFill>
-                  <a:srgbClr val="475569"/>
-                </a:solidFill>
-              </a:defRPr>
-            </a:pPr>
-            <a:r>
-              <a:t>Interactive UI dashboard rendering metrics and SQLite/PostgreSQL audit logging.</a:t>
+                  <a:srgbClr val="F8FAFC"/>
+                </a:solidFill>
+              </a:defRPr>
+            </a:pPr>
+            <a:r>
+              <a:t>All packet telemetry, inference verdicts, and latencies persist atomically to SQLite3 database (`nids.db`).</a:t>
             </a:r>
           </a:p>
         </p:txBody>
@@ -3961,13 +4816,13 @@
         <p:spPr>
           <a:xfrm>
             <a:off x="0" y="0"/>
-            <a:ext cx="12191695" cy="1097280"/>
+            <a:ext cx="12191695" cy="6858000"/>
           </a:xfrm>
           <a:prstGeom prst="rect">
             <a:avLst/>
           </a:prstGeom>
           <a:solidFill>
-            <a:srgbClr val="0F172A"/>
+            <a:srgbClr val="0B0F19"/>
           </a:solidFill>
           <a:ln>
             <a:noFill/>
@@ -4003,8 +4858,8 @@
         </p:nvSpPr>
         <p:spPr>
           <a:xfrm>
-            <a:off x="731520" y="137160"/>
-            <a:ext cx="10698480" cy="822960"/>
+            <a:off x="731520" y="457200"/>
+            <a:ext cx="10728655" cy="1005840"/>
           </a:xfrm>
           <a:prstGeom prst="rect">
             <a:avLst/>
@@ -4018,26 +4873,26 @@
           <a:lstStyle/>
           <a:p>
             <a:pPr>
-              <a:defRPr sz="2400" b="1">
-                <a:solidFill>
-                  <a:srgbClr val="FFFFFF"/>
-                </a:solidFill>
-              </a:defRPr>
-            </a:pPr>
-            <a:r>
-              <a:t>4. Deep Learning &amp; ML Methodology</a:t>
-            </a:r>
-          </a:p>
-          <a:p>
-            <a:pPr>
-              <a:defRPr sz="1100">
-                <a:solidFill>
-                  <a:srgbClr val="94A3B8"/>
-                </a:solidFill>
-              </a:defRPr>
-            </a:pPr>
-            <a:r>
-              <a:t>Academic &amp; Industrial AI Project Series  |  Project 02 of 55</a:t>
+              <a:defRPr sz="1100" b="1">
+                <a:solidFill>
+                  <a:srgbClr val="38BDF8"/>
+                </a:solidFill>
+              </a:defRPr>
+            </a:pPr>
+            <a:r>
+              <a:t>CYBERSHIELD AI / NETWORK SECURITY</a:t>
+            </a:r>
+          </a:p>
+          <a:p>
+            <a:pPr>
+              <a:defRPr sz="2200" b="1">
+                <a:solidFill>
+                  <a:srgbClr val="F8FAFC"/>
+                </a:solidFill>
+              </a:defRPr>
+            </a:pPr>
+            <a:r>
+              <a:t>NSL-KDD Benchmark Dataset &amp; Feature Engineering</a:t>
             </a:r>
           </a:p>
         </p:txBody>
@@ -4050,8 +4905,8 @@
         </p:nvSpPr>
         <p:spPr>
           <a:xfrm>
-            <a:off x="731520" y="1371600"/>
-            <a:ext cx="10698480" cy="5029200"/>
+            <a:off x="731520" y="1645920"/>
+            <a:ext cx="10728655" cy="4572000"/>
           </a:xfrm>
           <a:prstGeom prst="rect">
             <a:avLst/>
@@ -4063,112 +4918,88 @@
             <a:spAutoFit/>
           </a:bodyPr>
           <a:lstStyle/>
-          <a:p>
-            <a:pPr>
-              <a:spcBef>
-                <a:spcPts val="800"/>
-              </a:spcBef>
-              <a:defRPr sz="1500" b="1">
-                <a:solidFill>
-                  <a:srgbClr val="0F172A"/>
-                </a:solidFill>
-              </a:defRPr>
-            </a:pPr>
-            <a:r>
-              <a:t>• Feature Engineering &amp; Dimensionality Alignment</a:t>
-            </a:r>
-          </a:p>
-          <a:p>
-            <a:pPr>
-              <a:defRPr sz="1300">
-                <a:solidFill>
-                  <a:srgbClr val="475569"/>
-                </a:solidFill>
-              </a:defRPr>
-            </a:pPr>
-            <a:r>
-              <a:t>Domain-specific feature extraction, temporal windowing, and embedding vectors.</a:t>
-            </a:r>
-          </a:p>
-          <a:p>
-            <a:pPr>
-              <a:spcBef>
-                <a:spcPts val="800"/>
-              </a:spcBef>
-              <a:defRPr sz="1500" b="1">
-                <a:solidFill>
-                  <a:srgbClr val="0F172A"/>
-                </a:solidFill>
-              </a:defRPr>
-            </a:pPr>
-            <a:r>
-              <a:t>• Model Family &amp; Optimization</a:t>
-            </a:r>
-          </a:p>
-          <a:p>
-            <a:pPr>
-              <a:defRPr sz="1300">
-                <a:solidFill>
-                  <a:srgbClr val="475569"/>
-                </a:solidFill>
-              </a:defRPr>
-            </a:pPr>
-            <a:r>
-              <a:t>Ensemble gradient boosting or deep neural networks trained with AdamW and adaptive LR scheduling.</a:t>
-            </a:r>
-          </a:p>
-          <a:p>
-            <a:pPr>
-              <a:spcBef>
-                <a:spcPts val="800"/>
-              </a:spcBef>
-              <a:defRPr sz="1500" b="1">
-                <a:solidFill>
-                  <a:srgbClr val="0F172A"/>
-                </a:solidFill>
-              </a:defRPr>
-            </a:pPr>
-            <a:r>
-              <a:t>• Overfitting Mitigation</a:t>
-            </a:r>
-          </a:p>
-          <a:p>
-            <a:pPr>
-              <a:defRPr sz="1300">
-                <a:solidFill>
-                  <a:srgbClr val="475569"/>
-                </a:solidFill>
-              </a:defRPr>
-            </a:pPr>
-            <a:r>
-              <a:t>Stratified k-fold cross-validation, dropout layers, early stopping, and data augmentation.</a:t>
-            </a:r>
-          </a:p>
-          <a:p>
-            <a:pPr>
-              <a:spcBef>
-                <a:spcPts val="800"/>
-              </a:spcBef>
-              <a:defRPr sz="1500" b="1">
-                <a:solidFill>
-                  <a:srgbClr val="0F172A"/>
-                </a:solidFill>
-              </a:defRPr>
-            </a:pPr>
-            <a:r>
-              <a:t>• Explainability &amp; Auditability</a:t>
-            </a:r>
-          </a:p>
-          <a:p>
-            <a:pPr>
-              <a:defRPr sz="1300">
-                <a:solidFill>
-                  <a:srgbClr val="475569"/>
-                </a:solidFill>
-              </a:defRPr>
-            </a:pPr>
-            <a:r>
-              <a:t>Confidence scores and feature importance attributions for high-stakes decisions.</a:t>
+          <a:p/>
+          <a:p>
+            <a:pPr>
+              <a:defRPr b="1" sz="1400">
+                <a:solidFill>
+                  <a:srgbClr val="38BDF8"/>
+                </a:solidFill>
+              </a:defRPr>
+            </a:pPr>
+            <a:r>
+              <a:t>📊 Dataset Provenance: </a:t>
+            </a:r>
+            <a:r>
+              <a:rPr b="0">
+                <a:solidFill>
+                  <a:srgbClr val="F8FAFC"/>
+                </a:solidFill>
+              </a:rPr>
+              <a:t>NSL-KDD Network Intrusion Benchmark (University of New Brunswick / DARPA). Resolves redundant records present in legacy KDD'99 to ensure unbiased evaluation.</a:t>
+            </a:r>
+          </a:p>
+          <a:p>
+            <a:pPr>
+              <a:defRPr b="1" sz="1400">
+                <a:solidFill>
+                  <a:srgbClr val="38BDF8"/>
+                </a:solidFill>
+              </a:defRPr>
+            </a:pPr>
+            <a:r>
+              <a:t>📊 Dataset Volume: </a:t>
+            </a:r>
+            <a:r>
+              <a:rPr b="0">
+                <a:solidFill>
+                  <a:srgbClr val="F8FAFC"/>
+                </a:solidFill>
+              </a:rPr>
+              <a:t>22,544 full connection records. Partitioned into 18,035 training samples (80%) and 4,509 held-out testing samples (20%).</a:t>
+            </a:r>
+          </a:p>
+          <a:p>
+            <a:pPr>
+              <a:defRPr b="1" sz="1400">
+                <a:solidFill>
+                  <a:srgbClr val="38BDF8"/>
+                </a:solidFill>
+              </a:defRPr>
+            </a:pPr>
+            <a:r>
+              <a:t>📊 Feature Groups: </a:t>
+            </a:r>
+            <a:r>
+              <a:rPr b="0">
+                <a:solidFill>
+                  <a:srgbClr val="F8FAFC"/>
+                </a:solidFill>
+              </a:rPr>
+              <a:t>• Basic Features: duration, protocol_type, service, flag, src_bytes, dst_bytes
+• Content Features: hot, num_failed_logins, logged_in, num_compromised, root_shell, su_attempted
+• Time-based Traffic Features: count, srv_count, serror_rate, rerror_rate, same_srv_rate
+• Host-based Traffic Features: dst_host_count, dst_host_srv_count, dst_host_diff_srv_rate</a:t>
+            </a:r>
+          </a:p>
+          <a:p>
+            <a:pPr>
+              <a:defRPr b="1" sz="1400">
+                <a:solidFill>
+                  <a:srgbClr val="38BDF8"/>
+                </a:solidFill>
+              </a:defRPr>
+            </a:pPr>
+            <a:r>
+              <a:t>📊 Dimensional Transformation: </a:t>
+            </a:r>
+            <a:r>
+              <a:rPr b="0">
+                <a:solidFill>
+                  <a:srgbClr val="F8FAFC"/>
+                </a:solidFill>
+              </a:rPr>
+              <a:t>One-hot expansion across protocol services (http, private, telnet, ftp, smtp, etc.) and connection flags yields an expanded 111-dimensional feature space.</a:t>
             </a:r>
           </a:p>
         </p:txBody>
@@ -4200,13 +5031,13 @@
         <p:spPr>
           <a:xfrm>
             <a:off x="0" y="0"/>
-            <a:ext cx="12191695" cy="1097280"/>
+            <a:ext cx="12191695" cy="6858000"/>
           </a:xfrm>
           <a:prstGeom prst="rect">
             <a:avLst/>
           </a:prstGeom>
           <a:solidFill>
-            <a:srgbClr val="0F172A"/>
+            <a:srgbClr val="0B0F19"/>
           </a:solidFill>
           <a:ln>
             <a:noFill/>
@@ -4242,8 +5073,8 @@
         </p:nvSpPr>
         <p:spPr>
           <a:xfrm>
-            <a:off x="731520" y="137160"/>
-            <a:ext cx="10698480" cy="822960"/>
+            <a:off x="731520" y="457200"/>
+            <a:ext cx="10728655" cy="1005840"/>
           </a:xfrm>
           <a:prstGeom prst="rect">
             <a:avLst/>
@@ -4257,26 +5088,26 @@
           <a:lstStyle/>
           <a:p>
             <a:pPr>
-              <a:defRPr sz="2400" b="1">
-                <a:solidFill>
-                  <a:srgbClr val="FFFFFF"/>
-                </a:solidFill>
-              </a:defRPr>
-            </a:pPr>
-            <a:r>
-              <a:t>5. Experimental Results &amp; Performance Benchmarks</a:t>
-            </a:r>
-          </a:p>
-          <a:p>
-            <a:pPr>
-              <a:defRPr sz="1100">
-                <a:solidFill>
-                  <a:srgbClr val="94A3B8"/>
-                </a:solidFill>
-              </a:defRPr>
-            </a:pPr>
-            <a:r>
-              <a:t>Academic &amp; Industrial AI Project Series  |  Project 02 of 55</a:t>
+              <a:defRPr sz="1100" b="1">
+                <a:solidFill>
+                  <a:srgbClr val="38BDF8"/>
+                </a:solidFill>
+              </a:defRPr>
+            </a:pPr>
+            <a:r>
+              <a:t>CYBERSHIELD AI / NETWORK SECURITY</a:t>
+            </a:r>
+          </a:p>
+          <a:p>
+            <a:pPr>
+              <a:defRPr sz="2200" b="1">
+                <a:solidFill>
+                  <a:srgbClr val="F8FAFC"/>
+                </a:solidFill>
+              </a:defRPr>
+            </a:pPr>
+            <a:r>
+              <a:t>Ensemble Machine Learning Architecture</a:t>
             </a:r>
           </a:p>
         </p:txBody>
@@ -4289,8 +5120,8 @@
         </p:nvSpPr>
         <p:spPr>
           <a:xfrm>
-            <a:off x="731520" y="1371600"/>
-            <a:ext cx="10698480" cy="5029200"/>
+            <a:off x="731520" y="1645920"/>
+            <a:ext cx="10728655" cy="4572000"/>
           </a:xfrm>
           <a:prstGeom prst="rect">
             <a:avLst/>
@@ -4302,64 +5133,85 @@
             <a:spAutoFit/>
           </a:bodyPr>
           <a:lstStyle/>
-          <a:p>
-            <a:pPr>
-              <a:spcBef>
-                <a:spcPts val="1200"/>
-              </a:spcBef>
-              <a:defRPr sz="1500" b="1">
+          <a:p/>
+          <a:p>
+            <a:pPr>
+              <a:defRPr b="1" sz="1400">
                 <a:solidFill>
                   <a:srgbClr val="10B981"/>
                 </a:solidFill>
               </a:defRPr>
             </a:pPr>
             <a:r>
-              <a:t>★ Validation Accuracy / Score: Achieved 94.8% on independent validation test holdout partitions.</a:t>
-            </a:r>
-          </a:p>
-          <a:p>
-            <a:pPr>
-              <a:spcBef>
-                <a:spcPts val="1200"/>
-              </a:spcBef>
-              <a:defRPr sz="1500" b="1">
+              <a:t>🌳 Ensemble Strategy: Soft-Voting Hybrid: </a:t>
+            </a:r>
+            <a:r>
+              <a:rPr b="0">
+                <a:solidFill>
+                  <a:srgbClr val="F8FAFC"/>
+                </a:solidFill>
+              </a:rPr>
+              <a:t>Combines bootstrap-aggregated Random Forest with Extremely Randomized Trees (Extra Trees) to minimize both variance and feature correlation.</a:t>
+            </a:r>
+          </a:p>
+          <a:p>
+            <a:pPr>
+              <a:defRPr b="1" sz="1400">
                 <a:solidFill>
                   <a:srgbClr val="10B981"/>
                 </a:solidFill>
               </a:defRPr>
             </a:pPr>
             <a:r>
-              <a:t>★ F1-Score / Macro Precision: Balanced metric of 0.932 across positive and negative classification targets.</a:t>
-            </a:r>
-          </a:p>
-          <a:p>
-            <a:pPr>
-              <a:spcBef>
-                <a:spcPts val="1200"/>
-              </a:spcBef>
-              <a:defRPr sz="1500" b="1">
+              <a:t>🌳 Random Forest Classifier (100 Trees): </a:t>
+            </a:r>
+            <a:r>
+              <a:rPr b="0">
+                <a:solidFill>
+                  <a:srgbClr val="F8FAFC"/>
+                </a:solidFill>
+              </a:rPr>
+              <a:t>Evaluates sub-sampled feature splits with Gini impurity. Achieves 98.34% test accuracy and 0.9833 weighted F1-score across 5 attack classes.</a:t>
+            </a:r>
+          </a:p>
+          <a:p>
+            <a:pPr>
+              <a:defRPr b="1" sz="1400">
                 <a:solidFill>
                   <a:srgbClr val="10B981"/>
                 </a:solidFill>
               </a:defRPr>
             </a:pPr>
             <a:r>
-              <a:t>★ Inference Latency Profile: Median latency of 18.4 ms per inference query on edge CPU hardware.</a:t>
-            </a:r>
-          </a:p>
-          <a:p>
-            <a:pPr>
-              <a:spcBef>
-                <a:spcPts val="1200"/>
-              </a:spcBef>
-              <a:defRPr sz="1500" b="1">
+              <a:t>🌳 Extra Trees Classifier (100 Trees): </a:t>
+            </a:r>
+            <a:r>
+              <a:rPr b="0">
+                <a:solidFill>
+                  <a:srgbClr val="F8FAFC"/>
+                </a:solidFill>
+              </a:rPr>
+              <a:t>Randomizes split cutpoints for faster convergence and enhanced generalization on rare intrusion classes. Achieves 98.03% test accuracy and 0.9800 weighted F1-score.</a:t>
+            </a:r>
+          </a:p>
+          <a:p>
+            <a:pPr>
+              <a:defRPr b="1" sz="1400">
                 <a:solidFill>
                   <a:srgbClr val="10B981"/>
                 </a:solidFill>
               </a:defRPr>
             </a:pPr>
             <a:r>
-              <a:t>★ False Positive Rate (FPR): Maintained below 2.8%, satisfying stringent operational false alarm constraints.</a:t>
+              <a:t>🌳 Consensus &amp; Soft Probability Weighting: </a:t>
+            </a:r>
+            <a:r>
+              <a:rPr b="0">
+                <a:solidFill>
+                  <a:srgbClr val="F8FAFC"/>
+                </a:solidFill>
+              </a:rPr>
+              <a:t>Final multi-class probability is synthesized via: P(y=c|x) = 0.55 * P_RF(c|x) + 0.45 * P_ET(c|x). Provides calibrated confidence scoring for SOC operators.</a:t>
             </a:r>
           </a:p>
         </p:txBody>
@@ -4391,13 +5243,13 @@
         <p:spPr>
           <a:xfrm>
             <a:off x="0" y="0"/>
-            <a:ext cx="12191695" cy="1097280"/>
+            <a:ext cx="12191695" cy="6858000"/>
           </a:xfrm>
           <a:prstGeom prst="rect">
             <a:avLst/>
           </a:prstGeom>
           <a:solidFill>
-            <a:srgbClr val="0F172A"/>
+            <a:srgbClr val="0B0F19"/>
           </a:solidFill>
           <a:ln>
             <a:noFill/>
@@ -4433,8 +5285,8 @@
         </p:nvSpPr>
         <p:spPr>
           <a:xfrm>
-            <a:off x="731520" y="137160"/>
-            <a:ext cx="10698480" cy="822960"/>
+            <a:off x="731520" y="457200"/>
+            <a:ext cx="10728655" cy="1005840"/>
           </a:xfrm>
           <a:prstGeom prst="rect">
             <a:avLst/>
@@ -4448,26 +5300,26 @@
           <a:lstStyle/>
           <a:p>
             <a:pPr>
-              <a:defRPr sz="2400" b="1">
-                <a:solidFill>
-                  <a:srgbClr val="FFFFFF"/>
-                </a:solidFill>
-              </a:defRPr>
-            </a:pPr>
-            <a:r>
-              <a:t>6. Technology Stack &amp; Production Deployment</a:t>
-            </a:r>
-          </a:p>
-          <a:p>
-            <a:pPr>
-              <a:defRPr sz="1100">
-                <a:solidFill>
-                  <a:srgbClr val="94A3B8"/>
-                </a:solidFill>
-              </a:defRPr>
-            </a:pPr>
-            <a:r>
-              <a:t>Academic &amp; Industrial AI Project Series  |  Project 02 of 55</a:t>
+              <a:defRPr sz="1100" b="1">
+                <a:solidFill>
+                  <a:srgbClr val="38BDF8"/>
+                </a:solidFill>
+              </a:defRPr>
+            </a:pPr>
+            <a:r>
+              <a:t>CYBERSHIELD AI / NETWORK SECURITY</a:t>
+            </a:r>
+          </a:p>
+          <a:p>
+            <a:pPr>
+              <a:defRPr sz="2200" b="1">
+                <a:solidFill>
+                  <a:srgbClr val="F8FAFC"/>
+                </a:solidFill>
+              </a:defRPr>
+            </a:pPr>
+            <a:r>
+              <a:t>Unsupervised Anomaly Detection (Isolation Forest)</a:t>
             </a:r>
           </a:p>
         </p:txBody>
@@ -4480,8 +5332,8 @@
         </p:nvSpPr>
         <p:spPr>
           <a:xfrm>
-            <a:off x="731520" y="1371600"/>
-            <a:ext cx="10698480" cy="5029200"/>
+            <a:off x="731520" y="1645920"/>
+            <a:ext cx="10728655" cy="4572000"/>
           </a:xfrm>
           <a:prstGeom prst="rect">
             <a:avLst/>
@@ -4493,112 +5345,85 @@
             <a:spAutoFit/>
           </a:bodyPr>
           <a:lstStyle/>
-          <a:p>
-            <a:pPr>
-              <a:spcBef>
-                <a:spcPts val="800"/>
-              </a:spcBef>
-              <a:defRPr sz="1500" b="1">
-                <a:solidFill>
-                  <a:srgbClr val="1E3A8A"/>
-                </a:solidFill>
-              </a:defRPr>
-            </a:pPr>
-            <a:r>
-              <a:t>⚙ Core Machine Learning Framework</a:t>
-            </a:r>
-          </a:p>
-          <a:p>
-            <a:pPr>
-              <a:defRPr sz="1300">
-                <a:solidFill>
-                  <a:srgbClr val="475569"/>
-                </a:solidFill>
-              </a:defRPr>
-            </a:pPr>
-            <a:r>
-              <a:t>PyTorch 2.0+ / Scikit-learn / HuggingFace Transformers / OpenCV</a:t>
-            </a:r>
-          </a:p>
-          <a:p>
-            <a:pPr>
-              <a:spcBef>
-                <a:spcPts val="800"/>
-              </a:spcBef>
-              <a:defRPr sz="1500" b="1">
-                <a:solidFill>
-                  <a:srgbClr val="1E3A8A"/>
-                </a:solidFill>
-              </a:defRPr>
-            </a:pPr>
-            <a:r>
-              <a:t>⚙ Asynchronous REST Backend</a:t>
-            </a:r>
-          </a:p>
-          <a:p>
-            <a:pPr>
-              <a:defRPr sz="1300">
-                <a:solidFill>
-                  <a:srgbClr val="475569"/>
-                </a:solidFill>
-              </a:defRPr>
-            </a:pPr>
-            <a:r>
-              <a:t>FastAPI / Uvicorn ASGI Server / Pydantic V2 Type Safety</a:t>
-            </a:r>
-          </a:p>
-          <a:p>
-            <a:pPr>
-              <a:spcBef>
-                <a:spcPts val="800"/>
-              </a:spcBef>
-              <a:defRPr sz="1500" b="1">
-                <a:solidFill>
-                  <a:srgbClr val="1E3A8A"/>
-                </a:solidFill>
-              </a:defRPr>
-            </a:pPr>
-            <a:r>
-              <a:t>⚙ Data Persistence &amp; Storage</a:t>
-            </a:r>
-          </a:p>
-          <a:p>
-            <a:pPr>
-              <a:defRPr sz="1300">
-                <a:solidFill>
-                  <a:srgbClr val="475569"/>
-                </a:solidFill>
-              </a:defRPr>
-            </a:pPr>
-            <a:r>
-              <a:t>SQLite / PostgreSQL with transactional integrity &amp; audit trail</a:t>
-            </a:r>
-          </a:p>
-          <a:p>
-            <a:pPr>
-              <a:spcBef>
-                <a:spcPts val="800"/>
-              </a:spcBef>
-              <a:defRPr sz="1500" b="1">
-                <a:solidFill>
-                  <a:srgbClr val="1E3A8A"/>
-                </a:solidFill>
-              </a:defRPr>
-            </a:pPr>
-            <a:r>
-              <a:t>⚙ Interactive Frontend Layer</a:t>
-            </a:r>
-          </a:p>
-          <a:p>
-            <a:pPr>
-              <a:defRPr sz="1300">
-                <a:solidFill>
-                  <a:srgbClr val="475569"/>
-                </a:solidFill>
-              </a:defRPr>
-            </a:pPr>
-            <a:r>
-              <a:t>Modern Responsive Web Portal (HTML5, Tailwind/CSS, JavaScript ES6+)</a:t>
+          <a:p/>
+          <a:p>
+            <a:pPr>
+              <a:defRPr b="1" sz="1400">
+                <a:solidFill>
+                  <a:srgbClr val="A855F7"/>
+                </a:solidFill>
+              </a:defRPr>
+            </a:pPr>
+            <a:r>
+              <a:t>⚡ The Need for Unsupervised Detection: </a:t>
+            </a:r>
+            <a:r>
+              <a:rPr b="0">
+                <a:solidFill>
+                  <a:srgbClr val="F8FAFC"/>
+                </a:solidFill>
+              </a:rPr>
+              <a:t>Supervised models cannot classify attacks that have never been seen before. Zero-day exploits appear as novel clusters in high-dimensional feature space.</a:t>
+            </a:r>
+          </a:p>
+          <a:p>
+            <a:pPr>
+              <a:defRPr b="1" sz="1400">
+                <a:solidFill>
+                  <a:srgbClr val="A855F7"/>
+                </a:solidFill>
+              </a:defRPr>
+            </a:pPr>
+            <a:r>
+              <a:t>⚡ Isolation Forest Mechanism: </a:t>
+            </a:r>
+            <a:r>
+              <a:rPr b="0">
+                <a:solidFill>
+                  <a:srgbClr val="F8FAFC"/>
+                </a:solidFill>
+              </a:rPr>
+              <a:t>Isolates anomalies by recursively partitioning feature dimensions. Anomalous points require significantly fewer partitions (shorter path lengths) to isolate: s(x, n) = 2^(-E(h(x)) / c(n)).</a:t>
+            </a:r>
+          </a:p>
+          <a:p>
+            <a:pPr>
+              <a:defRPr b="1" sz="1400">
+                <a:solidFill>
+                  <a:srgbClr val="A855F7"/>
+                </a:solidFill>
+              </a:defRPr>
+            </a:pPr>
+            <a:r>
+              <a:t>⚡ Contamination Tuning: </a:t>
+            </a:r>
+            <a:r>
+              <a:rPr b="0">
+                <a:solidFill>
+                  <a:srgbClr val="F8FAFC"/>
+                </a:solidFill>
+              </a:rPr>
+              <a:t>Configured with contamination = 0.18 to match realistic perimeter intrusion proportions.</a:t>
+            </a:r>
+          </a:p>
+          <a:p>
+            <a:pPr>
+              <a:defRPr b="1" sz="1400">
+                <a:solidFill>
+                  <a:srgbClr val="A855F7"/>
+                </a:solidFill>
+              </a:defRPr>
+            </a:pPr>
+            <a:r>
+              <a:t>⚡ Dual Alert Threshold: </a:t>
+            </a:r>
+            <a:r>
+              <a:rPr b="0">
+                <a:solidFill>
+                  <a:srgbClr val="F8FAFC"/>
+                </a:solidFill>
+              </a:rPr>
+              <a:t>When supervised ensemble classifies a packet as 'Normal' but Isolation Forest yields an anomaly risk &gt; 55%, the system elevates threat status to 'SUSPICIOUS_ANOMALY' and routes packet to a secure sandbox.</a:t>
             </a:r>
           </a:p>
         </p:txBody>
@@ -4630,13 +5455,13 @@
         <p:spPr>
           <a:xfrm>
             <a:off x="0" y="0"/>
-            <a:ext cx="12191695" cy="1097280"/>
+            <a:ext cx="12191695" cy="6858000"/>
           </a:xfrm>
           <a:prstGeom prst="rect">
             <a:avLst/>
           </a:prstGeom>
           <a:solidFill>
-            <a:srgbClr val="0F172A"/>
+            <a:srgbClr val="0B0F19"/>
           </a:solidFill>
           <a:ln>
             <a:noFill/>
@@ -4672,8 +5497,8 @@
         </p:nvSpPr>
         <p:spPr>
           <a:xfrm>
-            <a:off x="731520" y="137160"/>
-            <a:ext cx="10698480" cy="822960"/>
+            <a:off x="731520" y="457200"/>
+            <a:ext cx="10728655" cy="1005840"/>
           </a:xfrm>
           <a:prstGeom prst="rect">
             <a:avLst/>
@@ -4687,40 +5512,125 @@
           <a:lstStyle/>
           <a:p>
             <a:pPr>
-              <a:defRPr sz="2400" b="1">
-                <a:solidFill>
-                  <a:srgbClr val="FFFFFF"/>
-                </a:solidFill>
-              </a:defRPr>
-            </a:pPr>
-            <a:r>
-              <a:t>7. Conclusion &amp; Future Roadmap</a:t>
-            </a:r>
-          </a:p>
-          <a:p>
-            <a:pPr>
-              <a:defRPr sz="1100">
-                <a:solidFill>
-                  <a:srgbClr val="94A3B8"/>
-                </a:solidFill>
-              </a:defRPr>
-            </a:pPr>
-            <a:r>
-              <a:t>Academic &amp; Industrial AI Project Series  |  Project 02 of 55</a:t>
-            </a:r>
-          </a:p>
-        </p:txBody>
-      </p:sp>
-      <p:sp>
-        <p:nvSpPr>
-          <p:cNvPr id="4" name="TextBox 3"/>
+              <a:defRPr sz="1100" b="1">
+                <a:solidFill>
+                  <a:srgbClr val="38BDF8"/>
+                </a:solidFill>
+              </a:defRPr>
+            </a:pPr>
+            <a:r>
+              <a:t>APPLICATION DEMONSTRATION</a:t>
+            </a:r>
+          </a:p>
+          <a:p>
+            <a:pPr>
+              <a:defRPr sz="2200" b="1">
+                <a:solidFill>
+                  <a:srgbClr val="F8FAFC"/>
+                </a:solidFill>
+              </a:defRPr>
+            </a:pPr>
+            <a:r>
+              <a:t>SOC Operations Portal &amp; Real-Time Packet Inspector</a:t>
+            </a:r>
+          </a:p>
+        </p:txBody>
+      </p:sp>
+      <p:pic>
+        <p:nvPicPr>
+          <p:cNvPr id="4" name="Picture 3" descr="01_soc_landing_inspector.png"/>
+          <p:cNvPicPr>
+            <a:picLocks noChangeAspect="1"/>
+          </p:cNvPicPr>
+          <p:nvPr/>
+        </p:nvPicPr>
+        <p:blipFill>
+          <a:blip r:embed="rId2"/>
+          <a:stretch>
+            <a:fillRect/>
+          </a:stretch>
+        </p:blipFill>
+        <p:spPr>
+          <a:xfrm>
+            <a:off x="731520" y="1463040"/>
+            <a:ext cx="10728655" cy="4754880"/>
+          </a:xfrm>
+          <a:prstGeom prst="rect">
+            <a:avLst/>
+          </a:prstGeom>
+        </p:spPr>
+      </p:pic>
+    </p:spTree>
+  </p:cSld>
+  <p:clrMapOvr>
+    <a:masterClrMapping/>
+  </p:clrMapOvr>
+</p:sld>
+</file>
+
+<file path=ppt/slides/slide9.xml><?xml version="1.0" encoding="utf-8"?>
+<p:sld xmlns:a="http://schemas.openxmlformats.org/drawingml/2006/main" xmlns:p="http://schemas.openxmlformats.org/presentationml/2006/main" xmlns:r="http://schemas.openxmlformats.org/officeDocument/2006/relationships">
+  <p:cSld>
+    <p:spTree>
+      <p:nvGrpSpPr>
+        <p:cNvPr id="1" name=""/>
+        <p:cNvGrpSpPr/>
+        <p:nvPr/>
+      </p:nvGrpSpPr>
+      <p:grpSpPr/>
+      <p:sp>
+        <p:nvSpPr>
+          <p:cNvPr id="2" name="Rectangle 1"/>
+          <p:cNvSpPr/>
+          <p:nvPr/>
+        </p:nvSpPr>
+        <p:spPr>
+          <a:xfrm>
+            <a:off x="0" y="0"/>
+            <a:ext cx="12191695" cy="6858000"/>
+          </a:xfrm>
+          <a:prstGeom prst="rect">
+            <a:avLst/>
+          </a:prstGeom>
+          <a:solidFill>
+            <a:srgbClr val="0B0F19"/>
+          </a:solidFill>
+          <a:ln>
+            <a:noFill/>
+          </a:ln>
+        </p:spPr>
+        <p:style>
+          <a:lnRef idx="1">
+            <a:schemeClr val="accent1"/>
+          </a:lnRef>
+          <a:fillRef idx="3">
+            <a:schemeClr val="accent1"/>
+          </a:fillRef>
+          <a:effectRef idx="2">
+            <a:schemeClr val="accent1"/>
+          </a:effectRef>
+          <a:fontRef idx="minor">
+            <a:schemeClr val="lt1"/>
+          </a:fontRef>
+        </p:style>
+        <p:txBody>
+          <a:bodyPr rtlCol="0" anchor="ctr"/>
+          <a:lstStyle/>
+          <a:p>
+            <a:pPr algn="ctr"/>
+          </a:p>
+        </p:txBody>
+      </p:sp>
+      <p:sp>
+        <p:nvSpPr>
+          <p:cNvPr id="3" name="TextBox 2"/>
           <p:cNvSpPr txBox="1"/>
           <p:nvPr/>
         </p:nvSpPr>
         <p:spPr>
           <a:xfrm>
-            <a:off x="731520" y="1371600"/>
-            <a:ext cx="10698480" cy="5029200"/>
+            <a:off x="731520" y="457200"/>
+            <a:ext cx="10728655" cy="1005840"/>
           </a:xfrm>
           <a:prstGeom prst="rect">
             <a:avLst/>
@@ -4734,87 +5644,54 @@
           <a:lstStyle/>
           <a:p>
             <a:pPr>
-              <a:spcBef>
-                <a:spcPts val="1000"/>
-              </a:spcBef>
-              <a:defRPr sz="1500" b="1">
-                <a:solidFill>
-                  <a:srgbClr val="0F172A"/>
-                </a:solidFill>
-              </a:defRPr>
-            </a:pPr>
-            <a:r>
-              <a:t>■ Project Accomplishments</a:t>
-            </a:r>
-          </a:p>
-          <a:p>
-            <a:pPr>
-              <a:defRPr sz="1300">
-                <a:solidFill>
-                  <a:srgbClr val="475569"/>
-                </a:solidFill>
-              </a:defRPr>
-            </a:pPr>
-            <a:r>
-              <a:t>Engineered a robust, end-to-end prototype validating the initial abstract with reproducible experiments.</a:t>
-            </a:r>
-          </a:p>
-          <a:p>
-            <a:pPr>
-              <a:spcBef>
-                <a:spcPts val="1000"/>
-              </a:spcBef>
-              <a:defRPr sz="1500" b="1">
-                <a:solidFill>
-                  <a:srgbClr val="0F172A"/>
-                </a:solidFill>
-              </a:defRPr>
-            </a:pPr>
-            <a:r>
-              <a:t>■ Industrial Significance</a:t>
-            </a:r>
-          </a:p>
-          <a:p>
-            <a:pPr>
-              <a:defRPr sz="1300">
-                <a:solidFill>
-                  <a:srgbClr val="475569"/>
-                </a:solidFill>
-              </a:defRPr>
-            </a:pPr>
-            <a:r>
-              <a:t>Eliminates latency and manual friction while ensuring high confidence automated decision support.</a:t>
-            </a:r>
-          </a:p>
-          <a:p>
-            <a:pPr>
-              <a:spcBef>
-                <a:spcPts val="1000"/>
-              </a:spcBef>
-              <a:defRPr sz="1500" b="1">
-                <a:solidFill>
-                  <a:srgbClr val="0F172A"/>
-                </a:solidFill>
-              </a:defRPr>
-            </a:pPr>
-            <a:r>
-              <a:t>■ Future Scope &amp; Extensions</a:t>
-            </a:r>
-          </a:p>
-          <a:p>
-            <a:pPr>
-              <a:defRPr sz="1300">
-                <a:solidFill>
-                  <a:srgbClr val="475569"/>
-                </a:solidFill>
-              </a:defRPr>
-            </a:pPr>
-            <a:r>
-              <a:t>Integration with federated edge sensors, distributed multi-tenant cloud clustering, and automated active learning.</a:t>
-            </a:r>
-          </a:p>
-        </p:txBody>
-      </p:sp>
+              <a:defRPr sz="1100" b="1">
+                <a:solidFill>
+                  <a:srgbClr val="38BDF8"/>
+                </a:solidFill>
+              </a:defRPr>
+            </a:pPr>
+            <a:r>
+              <a:t>ATTACK MITIGATION SCENARIO 1</a:t>
+            </a:r>
+          </a:p>
+          <a:p>
+            <a:pPr>
+              <a:defRPr sz="2200" b="1">
+                <a:solidFill>
+                  <a:srgbClr val="F8FAFC"/>
+                </a:solidFill>
+              </a:defRPr>
+            </a:pPr>
+            <a:r>
+              <a:t>Denial-of-Service Interception: Neptune SYN Flood</a:t>
+            </a:r>
+          </a:p>
+        </p:txBody>
+      </p:sp>
+      <p:pic>
+        <p:nvPicPr>
+          <p:cNvPr id="4" name="Picture 3" descr="02_neptune_syn_flood.png"/>
+          <p:cNvPicPr>
+            <a:picLocks noChangeAspect="1"/>
+          </p:cNvPicPr>
+          <p:nvPr/>
+        </p:nvPicPr>
+        <p:blipFill>
+          <a:blip r:embed="rId2"/>
+          <a:stretch>
+            <a:fillRect/>
+          </a:stretch>
+        </p:blipFill>
+        <p:spPr>
+          <a:xfrm>
+            <a:off x="731520" y="1463040"/>
+            <a:ext cx="10728655" cy="4754880"/>
+          </a:xfrm>
+          <a:prstGeom prst="rect">
+            <a:avLst/>
+          </a:prstGeom>
+        </p:spPr>
+      </p:pic>
     </p:spTree>
   </p:cSld>
   <p:clrMapOvr>

</xml_diff>